<commit_message>
Add hiring plan section (Section 5) to EN/JP HTML + PPTX slide 7
</commit_message>
<xml_diff>
--- a/ia-strategy-visual.pptx
+++ b/ia-strategy-visual.pptx
@@ -11,6 +11,7 @@
     <p:sldId id="259" r:id="rId10"/>
     <p:sldId id="260" r:id="rId11"/>
     <p:sldId id="261" r:id="rId12"/>
+    <p:sldId id="262" r:id="rId13"/>
   </p:sldIdLst>
   <p:sldSz cx="12191695" cy="6858000" type="screen4x3"/>
   <p:notesSz cx="6858000" cy="9144000"/>
@@ -19526,6 +19527,1548 @@
             </a:pPr>
             <a:r>
               <a:t>● Product packaging</a:t>
+            </a:r>
+          </a:p>
+        </p:txBody>
+      </p:sp>
+    </p:spTree>
+  </p:cSld>
+  <p:clrMapOvr>
+    <a:masterClrMapping/>
+  </p:clrMapOvr>
+</p:sld>
+</file>
+
+<file path=ppt/slides/slide7.xml><?xml version="1.0" encoding="utf-8"?>
+<p:sld xmlns:a="http://schemas.openxmlformats.org/drawingml/2006/main" xmlns:p="http://schemas.openxmlformats.org/presentationml/2006/main" xmlns:r="http://schemas.openxmlformats.org/officeDocument/2006/relationships">
+  <p:cSld>
+    <p:spTree>
+      <p:nvGrpSpPr>
+        <p:cNvPr id="1" name=""/>
+        <p:cNvGrpSpPr/>
+        <p:nvPr/>
+      </p:nvGrpSpPr>
+      <p:grpSpPr/>
+      <p:sp>
+        <p:nvSpPr>
+          <p:cNvPr id="2" name="Rectangle 1"/>
+          <p:cNvSpPr/>
+          <p:nvPr/>
+        </p:nvSpPr>
+        <p:spPr>
+          <a:xfrm>
+            <a:off x="0" y="0"/>
+            <a:ext cx="12191695" cy="6858000"/>
+          </a:xfrm>
+          <a:prstGeom prst="rect">
+            <a:avLst/>
+          </a:prstGeom>
+          <a:solidFill>
+            <a:srgbClr val="FFFFFF"/>
+          </a:solidFill>
+          <a:ln>
+            <a:noFill/>
+          </a:ln>
+        </p:spPr>
+        <p:style>
+          <a:lnRef idx="1">
+            <a:schemeClr val="accent1"/>
+          </a:lnRef>
+          <a:fillRef idx="3">
+            <a:schemeClr val="accent1"/>
+          </a:fillRef>
+          <a:effectRef idx="2">
+            <a:schemeClr val="accent1"/>
+          </a:effectRef>
+          <a:fontRef idx="minor">
+            <a:schemeClr val="lt1"/>
+          </a:fontRef>
+        </p:style>
+        <p:txBody>
+          <a:bodyPr rtlCol="0" anchor="ctr"/>
+          <a:lstStyle/>
+          <a:p>
+            <a:pPr algn="ctr"/>
+          </a:p>
+        </p:txBody>
+      </p:sp>
+      <p:sp>
+        <p:nvSpPr>
+          <p:cNvPr id="3" name="TextBox 2"/>
+          <p:cNvSpPr txBox="1"/>
+          <p:nvPr/>
+        </p:nvSpPr>
+        <p:spPr>
+          <a:xfrm>
+            <a:off x="457200" y="182880"/>
+            <a:ext cx="10972800" cy="457200"/>
+          </a:xfrm>
+          <a:prstGeom prst="rect">
+            <a:avLst/>
+          </a:prstGeom>
+          <a:noFill/>
+        </p:spPr>
+        <p:txBody>
+          <a:bodyPr wrap="none">
+            <a:spAutoFit/>
+          </a:bodyPr>
+          <a:lstStyle/>
+          <a:p>
+            <a:pPr>
+              <a:defRPr sz="2400" b="1">
+                <a:solidFill>
+                  <a:srgbClr val="1A237E"/>
+                </a:solidFill>
+              </a:defRPr>
+            </a:pPr>
+            <a:r>
+              <a:t>5 — HIRING PLAN: When and Who</a:t>
+            </a:r>
+          </a:p>
+        </p:txBody>
+      </p:sp>
+      <p:sp>
+        <p:nvSpPr>
+          <p:cNvPr id="4" name="TextBox 3"/>
+          <p:cNvSpPr txBox="1"/>
+          <p:nvPr/>
+        </p:nvSpPr>
+        <p:spPr>
+          <a:xfrm>
+            <a:off x="457200" y="685800"/>
+            <a:ext cx="10972800" cy="274320"/>
+          </a:xfrm>
+          <a:prstGeom prst="rect">
+            <a:avLst/>
+          </a:prstGeom>
+          <a:noFill/>
+        </p:spPr>
+        <p:txBody>
+          <a:bodyPr wrap="none">
+            <a:spAutoFit/>
+          </a:bodyPr>
+          <a:lstStyle/>
+          <a:p>
+            <a:pPr>
+              <a:defRPr sz="1200">
+                <a:solidFill>
+                  <a:srgbClr val="616161"/>
+                </a:solidFill>
+              </a:defRPr>
+            </a:pPr>
+            <a:r>
+              <a:t>Staffing Timeline — 3 Hires Staggered Across 18 Months (Current: 3 devs + 1 mgr → Target: 6 devs + 1 mgr)</a:t>
+            </a:r>
+          </a:p>
+        </p:txBody>
+      </p:sp>
+      <p:sp>
+        <p:nvSpPr>
+          <p:cNvPr id="5" name="TextBox 4"/>
+          <p:cNvSpPr txBox="1"/>
+          <p:nvPr/>
+        </p:nvSpPr>
+        <p:spPr>
+          <a:xfrm>
+            <a:off x="2103120" y="1051560"/>
+            <a:ext cx="1097280" cy="320040"/>
+          </a:xfrm>
+          <a:prstGeom prst="rect">
+            <a:avLst/>
+          </a:prstGeom>
+          <a:noFill/>
+        </p:spPr>
+        <p:txBody>
+          <a:bodyPr wrap="none">
+            <a:spAutoFit/>
+          </a:bodyPr>
+          <a:lstStyle/>
+          <a:p>
+            <a:pPr algn="ctr">
+              <a:defRPr sz="900" b="1">
+                <a:solidFill>
+                  <a:srgbClr val="1A237E"/>
+                </a:solidFill>
+              </a:defRPr>
+            </a:pPr>
+            <a:r>
+              <a:t>'26 H1</a:t>
+            </a:r>
+          </a:p>
+        </p:txBody>
+      </p:sp>
+      <p:sp>
+        <p:nvSpPr>
+          <p:cNvPr id="6" name="TextBox 5"/>
+          <p:cNvSpPr txBox="1"/>
+          <p:nvPr/>
+        </p:nvSpPr>
+        <p:spPr>
+          <a:xfrm>
+            <a:off x="3200400" y="1051560"/>
+            <a:ext cx="1097280" cy="320040"/>
+          </a:xfrm>
+          <a:prstGeom prst="rect">
+            <a:avLst/>
+          </a:prstGeom>
+          <a:noFill/>
+        </p:spPr>
+        <p:txBody>
+          <a:bodyPr wrap="none">
+            <a:spAutoFit/>
+          </a:bodyPr>
+          <a:lstStyle/>
+          <a:p>
+            <a:pPr algn="ctr">
+              <a:defRPr sz="900" b="1">
+                <a:solidFill>
+                  <a:srgbClr val="1A237E"/>
+                </a:solidFill>
+              </a:defRPr>
+            </a:pPr>
+            <a:r>
+              <a:t>'26 H2</a:t>
+            </a:r>
+          </a:p>
+        </p:txBody>
+      </p:sp>
+      <p:sp>
+        <p:nvSpPr>
+          <p:cNvPr id="7" name="TextBox 6"/>
+          <p:cNvSpPr txBox="1"/>
+          <p:nvPr/>
+        </p:nvSpPr>
+        <p:spPr>
+          <a:xfrm>
+            <a:off x="4297680" y="1051560"/>
+            <a:ext cx="1097280" cy="320040"/>
+          </a:xfrm>
+          <a:prstGeom prst="rect">
+            <a:avLst/>
+          </a:prstGeom>
+          <a:noFill/>
+        </p:spPr>
+        <p:txBody>
+          <a:bodyPr wrap="none">
+            <a:spAutoFit/>
+          </a:bodyPr>
+          <a:lstStyle/>
+          <a:p>
+            <a:pPr algn="ctr">
+              <a:defRPr sz="900" b="1">
+                <a:solidFill>
+                  <a:srgbClr val="1A237E"/>
+                </a:solidFill>
+              </a:defRPr>
+            </a:pPr>
+            <a:r>
+              <a:t>'27 H1</a:t>
+            </a:r>
+          </a:p>
+        </p:txBody>
+      </p:sp>
+      <p:sp>
+        <p:nvSpPr>
+          <p:cNvPr id="8" name="TextBox 7"/>
+          <p:cNvSpPr txBox="1"/>
+          <p:nvPr/>
+        </p:nvSpPr>
+        <p:spPr>
+          <a:xfrm>
+            <a:off x="5394960" y="1051560"/>
+            <a:ext cx="1097280" cy="320040"/>
+          </a:xfrm>
+          <a:prstGeom prst="rect">
+            <a:avLst/>
+          </a:prstGeom>
+          <a:noFill/>
+        </p:spPr>
+        <p:txBody>
+          <a:bodyPr wrap="none">
+            <a:spAutoFit/>
+          </a:bodyPr>
+          <a:lstStyle/>
+          <a:p>
+            <a:pPr algn="ctr">
+              <a:defRPr sz="900" b="1">
+                <a:solidFill>
+                  <a:srgbClr val="1A237E"/>
+                </a:solidFill>
+              </a:defRPr>
+            </a:pPr>
+            <a:r>
+              <a:t>'27 H2</a:t>
+            </a:r>
+          </a:p>
+        </p:txBody>
+      </p:sp>
+      <p:sp>
+        <p:nvSpPr>
+          <p:cNvPr id="9" name="TextBox 8"/>
+          <p:cNvSpPr txBox="1"/>
+          <p:nvPr/>
+        </p:nvSpPr>
+        <p:spPr>
+          <a:xfrm>
+            <a:off x="6492240" y="1051560"/>
+            <a:ext cx="1097280" cy="320040"/>
+          </a:xfrm>
+          <a:prstGeom prst="rect">
+            <a:avLst/>
+          </a:prstGeom>
+          <a:noFill/>
+        </p:spPr>
+        <p:txBody>
+          <a:bodyPr wrap="none">
+            <a:spAutoFit/>
+          </a:bodyPr>
+          <a:lstStyle/>
+          <a:p>
+            <a:pPr algn="ctr">
+              <a:defRPr sz="900" b="1">
+                <a:solidFill>
+                  <a:srgbClr val="1A237E"/>
+                </a:solidFill>
+              </a:defRPr>
+            </a:pPr>
+            <a:r>
+              <a:t>'28 H1</a:t>
+            </a:r>
+          </a:p>
+        </p:txBody>
+      </p:sp>
+      <p:sp>
+        <p:nvSpPr>
+          <p:cNvPr id="10" name="TextBox 9"/>
+          <p:cNvSpPr txBox="1"/>
+          <p:nvPr/>
+        </p:nvSpPr>
+        <p:spPr>
+          <a:xfrm>
+            <a:off x="7589520" y="1051560"/>
+            <a:ext cx="1097280" cy="320040"/>
+          </a:xfrm>
+          <a:prstGeom prst="rect">
+            <a:avLst/>
+          </a:prstGeom>
+          <a:noFill/>
+        </p:spPr>
+        <p:txBody>
+          <a:bodyPr wrap="none">
+            <a:spAutoFit/>
+          </a:bodyPr>
+          <a:lstStyle/>
+          <a:p>
+            <a:pPr algn="ctr">
+              <a:defRPr sz="900" b="1">
+                <a:solidFill>
+                  <a:srgbClr val="1A237E"/>
+                </a:solidFill>
+              </a:defRPr>
+            </a:pPr>
+            <a:r>
+              <a:t>'28 H2</a:t>
+            </a:r>
+          </a:p>
+        </p:txBody>
+      </p:sp>
+      <p:sp>
+        <p:nvSpPr>
+          <p:cNvPr id="11" name="TextBox 10"/>
+          <p:cNvSpPr txBox="1"/>
+          <p:nvPr/>
+        </p:nvSpPr>
+        <p:spPr>
+          <a:xfrm>
+            <a:off x="8686800" y="1051560"/>
+            <a:ext cx="1097280" cy="320040"/>
+          </a:xfrm>
+          <a:prstGeom prst="rect">
+            <a:avLst/>
+          </a:prstGeom>
+          <a:noFill/>
+        </p:spPr>
+        <p:txBody>
+          <a:bodyPr wrap="none">
+            <a:spAutoFit/>
+          </a:bodyPr>
+          <a:lstStyle/>
+          <a:p>
+            <a:pPr algn="ctr">
+              <a:defRPr sz="900" b="1">
+                <a:solidFill>
+                  <a:srgbClr val="1A237E"/>
+                </a:solidFill>
+              </a:defRPr>
+            </a:pPr>
+            <a:r>
+              <a:t>'29 H1</a:t>
+            </a:r>
+          </a:p>
+        </p:txBody>
+      </p:sp>
+      <p:sp>
+        <p:nvSpPr>
+          <p:cNvPr id="12" name="TextBox 11"/>
+          <p:cNvSpPr txBox="1"/>
+          <p:nvPr/>
+        </p:nvSpPr>
+        <p:spPr>
+          <a:xfrm>
+            <a:off x="9784080" y="1051560"/>
+            <a:ext cx="1097280" cy="320040"/>
+          </a:xfrm>
+          <a:prstGeom prst="rect">
+            <a:avLst/>
+          </a:prstGeom>
+          <a:noFill/>
+        </p:spPr>
+        <p:txBody>
+          <a:bodyPr wrap="none">
+            <a:spAutoFit/>
+          </a:bodyPr>
+          <a:lstStyle/>
+          <a:p>
+            <a:pPr algn="ctr">
+              <a:defRPr sz="900" b="1">
+                <a:solidFill>
+                  <a:srgbClr val="1A237E"/>
+                </a:solidFill>
+              </a:defRPr>
+            </a:pPr>
+            <a:r>
+              <a:t>'29 H2</a:t>
+            </a:r>
+          </a:p>
+        </p:txBody>
+      </p:sp>
+      <p:sp>
+        <p:nvSpPr>
+          <p:cNvPr id="13" name="TextBox 12"/>
+          <p:cNvSpPr txBox="1"/>
+          <p:nvPr/>
+        </p:nvSpPr>
+        <p:spPr>
+          <a:xfrm>
+            <a:off x="10881360" y="1051560"/>
+            <a:ext cx="1097280" cy="320040"/>
+          </a:xfrm>
+          <a:prstGeom prst="rect">
+            <a:avLst/>
+          </a:prstGeom>
+          <a:noFill/>
+        </p:spPr>
+        <p:txBody>
+          <a:bodyPr wrap="none">
+            <a:spAutoFit/>
+          </a:bodyPr>
+          <a:lstStyle/>
+          <a:p>
+            <a:pPr algn="ctr">
+              <a:defRPr sz="900" b="1">
+                <a:solidFill>
+                  <a:srgbClr val="1A237E"/>
+                </a:solidFill>
+              </a:defRPr>
+            </a:pPr>
+            <a:r>
+              <a:t>2029+</a:t>
+            </a:r>
+          </a:p>
+        </p:txBody>
+      </p:sp>
+      <p:sp>
+        <p:nvSpPr>
+          <p:cNvPr id="14" name="TextBox 13"/>
+          <p:cNvSpPr txBox="1"/>
+          <p:nvPr/>
+        </p:nvSpPr>
+        <p:spPr>
+          <a:xfrm>
+            <a:off x="457200" y="1508760"/>
+            <a:ext cx="1645920" cy="274320"/>
+          </a:xfrm>
+          <a:prstGeom prst="rect">
+            <a:avLst/>
+          </a:prstGeom>
+          <a:noFill/>
+        </p:spPr>
+        <p:txBody>
+          <a:bodyPr wrap="none">
+            <a:spAutoFit/>
+          </a:bodyPr>
+          <a:lstStyle/>
+          <a:p>
+            <a:pPr>
+              <a:defRPr sz="1100" b="1">
+                <a:solidFill>
+                  <a:srgbClr val="1E1E1E"/>
+                </a:solidFill>
+              </a:defRPr>
+            </a:pPr>
+            <a:r>
+              <a:t>📅 Hires</a:t>
+            </a:r>
+          </a:p>
+        </p:txBody>
+      </p:sp>
+      <p:sp>
+        <p:nvSpPr>
+          <p:cNvPr id="15" name="Rounded Rectangle 14"/>
+          <p:cNvSpPr/>
+          <p:nvPr/>
+        </p:nvSpPr>
+        <p:spPr>
+          <a:xfrm>
+            <a:off x="3218688" y="1508760"/>
+            <a:ext cx="1060704" cy="548640"/>
+          </a:xfrm>
+          <a:prstGeom prst="roundRect">
+            <a:avLst/>
+          </a:prstGeom>
+          <a:solidFill>
+            <a:srgbClr val="1565C0"/>
+          </a:solidFill>
+          <a:ln>
+            <a:noFill/>
+          </a:ln>
+        </p:spPr>
+        <p:style>
+          <a:lnRef idx="1">
+            <a:schemeClr val="accent1"/>
+          </a:lnRef>
+          <a:fillRef idx="3">
+            <a:schemeClr val="accent1"/>
+          </a:fillRef>
+          <a:effectRef idx="2">
+            <a:schemeClr val="accent1"/>
+          </a:effectRef>
+          <a:fontRef idx="minor">
+            <a:schemeClr val="lt1"/>
+          </a:fontRef>
+        </p:style>
+        <p:txBody>
+          <a:bodyPr rtlCol="0" anchor="ctr" wrap="square" lIns="36576" rIns="36576" tIns="18288" bIns="18288"/>
+          <a:lstStyle/>
+          <a:p>
+            <a:pPr algn="ctr">
+              <a:defRPr sz="800">
+                <a:solidFill>
+                  <a:srgbClr val="FFFFFF"/>
+                </a:solidFill>
+              </a:defRPr>
+            </a:pPr>
+            <a:r>
+              <a:t>Sep 2026</a:t>
+            </a:r>
+          </a:p>
+          <a:p>
+            <a:pPr algn="ctr">
+              <a:defRPr sz="900" b="1">
+                <a:solidFill>
+                  <a:srgbClr val="FFFFFF"/>
+                </a:solidFill>
+              </a:defRPr>
+            </a:pPr>
+            <a:r>
+              <a:t>Hire #1</a:t>
+            </a:r>
+          </a:p>
+        </p:txBody>
+      </p:sp>
+      <p:sp>
+        <p:nvSpPr>
+          <p:cNvPr id="16" name="Rounded Rectangle 15"/>
+          <p:cNvSpPr/>
+          <p:nvPr/>
+        </p:nvSpPr>
+        <p:spPr>
+          <a:xfrm>
+            <a:off x="4315968" y="1508760"/>
+            <a:ext cx="1060704" cy="548640"/>
+          </a:xfrm>
+          <a:prstGeom prst="roundRect">
+            <a:avLst/>
+          </a:prstGeom>
+          <a:solidFill>
+            <a:srgbClr val="00838F"/>
+          </a:solidFill>
+          <a:ln>
+            <a:noFill/>
+          </a:ln>
+        </p:spPr>
+        <p:style>
+          <a:lnRef idx="1">
+            <a:schemeClr val="accent1"/>
+          </a:lnRef>
+          <a:fillRef idx="3">
+            <a:schemeClr val="accent1"/>
+          </a:fillRef>
+          <a:effectRef idx="2">
+            <a:schemeClr val="accent1"/>
+          </a:effectRef>
+          <a:fontRef idx="minor">
+            <a:schemeClr val="lt1"/>
+          </a:fontRef>
+        </p:style>
+        <p:txBody>
+          <a:bodyPr rtlCol="0" anchor="ctr" wrap="square" lIns="36576" rIns="36576" tIns="18288" bIns="18288"/>
+          <a:lstStyle/>
+          <a:p>
+            <a:pPr algn="ctr">
+              <a:defRPr sz="800">
+                <a:solidFill>
+                  <a:srgbClr val="FFFFFF"/>
+                </a:solidFill>
+              </a:defRPr>
+            </a:pPr>
+            <a:r>
+              <a:t>Apr 2027</a:t>
+            </a:r>
+          </a:p>
+          <a:p>
+            <a:pPr algn="ctr">
+              <a:defRPr sz="900" b="1">
+                <a:solidFill>
+                  <a:srgbClr val="FFFFFF"/>
+                </a:solidFill>
+              </a:defRPr>
+            </a:pPr>
+            <a:r>
+              <a:t>Hire #2</a:t>
+            </a:r>
+          </a:p>
+        </p:txBody>
+      </p:sp>
+      <p:sp>
+        <p:nvSpPr>
+          <p:cNvPr id="17" name="Rounded Rectangle 16"/>
+          <p:cNvSpPr/>
+          <p:nvPr/>
+        </p:nvSpPr>
+        <p:spPr>
+          <a:xfrm>
+            <a:off x="6510528" y="1508760"/>
+            <a:ext cx="1060704" cy="548640"/>
+          </a:xfrm>
+          <a:prstGeom prst="roundRect">
+            <a:avLst/>
+          </a:prstGeom>
+          <a:solidFill>
+            <a:srgbClr val="6A1B9A"/>
+          </a:solidFill>
+          <a:ln>
+            <a:noFill/>
+          </a:ln>
+        </p:spPr>
+        <p:style>
+          <a:lnRef idx="1">
+            <a:schemeClr val="accent1"/>
+          </a:lnRef>
+          <a:fillRef idx="3">
+            <a:schemeClr val="accent1"/>
+          </a:fillRef>
+          <a:effectRef idx="2">
+            <a:schemeClr val="accent1"/>
+          </a:effectRef>
+          <a:fontRef idx="minor">
+            <a:schemeClr val="lt1"/>
+          </a:fontRef>
+        </p:style>
+        <p:txBody>
+          <a:bodyPr rtlCol="0" anchor="ctr" wrap="square" lIns="36576" rIns="36576" tIns="18288" bIns="18288"/>
+          <a:lstStyle/>
+          <a:p>
+            <a:pPr algn="ctr">
+              <a:defRPr sz="800">
+                <a:solidFill>
+                  <a:srgbClr val="FFFFFF"/>
+                </a:solidFill>
+              </a:defRPr>
+            </a:pPr>
+            <a:r>
+              <a:t>Jan 2028</a:t>
+            </a:r>
+          </a:p>
+          <a:p>
+            <a:pPr algn="ctr">
+              <a:defRPr sz="900" b="1">
+                <a:solidFill>
+                  <a:srgbClr val="FFFFFF"/>
+                </a:solidFill>
+              </a:defRPr>
+            </a:pPr>
+            <a:r>
+              <a:t>Hire #3</a:t>
+            </a:r>
+          </a:p>
+        </p:txBody>
+      </p:sp>
+      <p:sp>
+        <p:nvSpPr>
+          <p:cNvPr id="18" name="TextBox 17"/>
+          <p:cNvSpPr txBox="1"/>
+          <p:nvPr/>
+        </p:nvSpPr>
+        <p:spPr>
+          <a:xfrm>
+            <a:off x="457200" y="2240280"/>
+            <a:ext cx="1645920" cy="274320"/>
+          </a:xfrm>
+          <a:prstGeom prst="rect">
+            <a:avLst/>
+          </a:prstGeom>
+          <a:noFill/>
+        </p:spPr>
+        <p:txBody>
+          <a:bodyPr wrap="none">
+            <a:spAutoFit/>
+          </a:bodyPr>
+          <a:lstStyle/>
+          <a:p>
+            <a:pPr>
+              <a:defRPr sz="1100" b="1">
+                <a:solidFill>
+                  <a:srgbClr val="1E1E1E"/>
+                </a:solidFill>
+              </a:defRPr>
+            </a:pPr>
+            <a:r>
+              <a:t>👥 Team size</a:t>
+            </a:r>
+          </a:p>
+        </p:txBody>
+      </p:sp>
+      <p:sp>
+        <p:nvSpPr>
+          <p:cNvPr id="19" name="Rounded Rectangle 18"/>
+          <p:cNvSpPr/>
+          <p:nvPr/>
+        </p:nvSpPr>
+        <p:spPr>
+          <a:xfrm>
+            <a:off x="2121408" y="2240280"/>
+            <a:ext cx="2157984" cy="365760"/>
+          </a:xfrm>
+          <a:prstGeom prst="roundRect">
+            <a:avLst/>
+          </a:prstGeom>
+          <a:solidFill>
+            <a:srgbClr val="2E7D32"/>
+          </a:solidFill>
+          <a:ln>
+            <a:noFill/>
+          </a:ln>
+        </p:spPr>
+        <p:style>
+          <a:lnRef idx="1">
+            <a:schemeClr val="accent1"/>
+          </a:lnRef>
+          <a:fillRef idx="3">
+            <a:schemeClr val="accent1"/>
+          </a:fillRef>
+          <a:effectRef idx="2">
+            <a:schemeClr val="accent1"/>
+          </a:effectRef>
+          <a:fontRef idx="minor">
+            <a:schemeClr val="lt1"/>
+          </a:fontRef>
+        </p:style>
+        <p:txBody>
+          <a:bodyPr rtlCol="0" anchor="ctr" lIns="36576" rIns="36576"/>
+          <a:lstStyle/>
+          <a:p>
+            <a:pPr algn="ctr">
+              <a:defRPr sz="800" b="1">
+                <a:solidFill>
+                  <a:srgbClr val="FFFFFF"/>
+                </a:solidFill>
+              </a:defRPr>
+            </a:pPr>
+            <a:r>
+              <a:t>3 devs + 1 mgr</a:t>
+            </a:r>
+          </a:p>
+        </p:txBody>
+      </p:sp>
+      <p:sp>
+        <p:nvSpPr>
+          <p:cNvPr id="20" name="Rounded Rectangle 19"/>
+          <p:cNvSpPr/>
+          <p:nvPr/>
+        </p:nvSpPr>
+        <p:spPr>
+          <a:xfrm>
+            <a:off x="4315968" y="2240280"/>
+            <a:ext cx="2157984" cy="365760"/>
+          </a:xfrm>
+          <a:prstGeom prst="roundRect">
+            <a:avLst/>
+          </a:prstGeom>
+          <a:solidFill>
+            <a:srgbClr val="2E7D32"/>
+          </a:solidFill>
+          <a:ln>
+            <a:noFill/>
+          </a:ln>
+        </p:spPr>
+        <p:style>
+          <a:lnRef idx="1">
+            <a:schemeClr val="accent1"/>
+          </a:lnRef>
+          <a:fillRef idx="3">
+            <a:schemeClr val="accent1"/>
+          </a:fillRef>
+          <a:effectRef idx="2">
+            <a:schemeClr val="accent1"/>
+          </a:effectRef>
+          <a:fontRef idx="minor">
+            <a:schemeClr val="lt1"/>
+          </a:fontRef>
+        </p:style>
+        <p:txBody>
+          <a:bodyPr rtlCol="0" anchor="ctr" lIns="36576" rIns="36576"/>
+          <a:lstStyle/>
+          <a:p>
+            <a:pPr algn="ctr">
+              <a:defRPr sz="800" b="1">
+                <a:solidFill>
+                  <a:srgbClr val="FFFFFF"/>
+                </a:solidFill>
+              </a:defRPr>
+            </a:pPr>
+            <a:r>
+              <a:t>4 devs + 1 mgr</a:t>
+            </a:r>
+          </a:p>
+        </p:txBody>
+      </p:sp>
+      <p:sp>
+        <p:nvSpPr>
+          <p:cNvPr id="21" name="Rounded Rectangle 20"/>
+          <p:cNvSpPr/>
+          <p:nvPr/>
+        </p:nvSpPr>
+        <p:spPr>
+          <a:xfrm>
+            <a:off x="6510528" y="2240280"/>
+            <a:ext cx="2157984" cy="365760"/>
+          </a:xfrm>
+          <a:prstGeom prst="roundRect">
+            <a:avLst/>
+          </a:prstGeom>
+          <a:solidFill>
+            <a:srgbClr val="1565C0"/>
+          </a:solidFill>
+          <a:ln>
+            <a:noFill/>
+          </a:ln>
+        </p:spPr>
+        <p:style>
+          <a:lnRef idx="1">
+            <a:schemeClr val="accent1"/>
+          </a:lnRef>
+          <a:fillRef idx="3">
+            <a:schemeClr val="accent1"/>
+          </a:fillRef>
+          <a:effectRef idx="2">
+            <a:schemeClr val="accent1"/>
+          </a:effectRef>
+          <a:fontRef idx="minor">
+            <a:schemeClr val="lt1"/>
+          </a:fontRef>
+        </p:style>
+        <p:txBody>
+          <a:bodyPr rtlCol="0" anchor="ctr" lIns="36576" rIns="36576"/>
+          <a:lstStyle/>
+          <a:p>
+            <a:pPr algn="ctr">
+              <a:defRPr sz="800" b="1">
+                <a:solidFill>
+                  <a:srgbClr val="FFFFFF"/>
+                </a:solidFill>
+              </a:defRPr>
+            </a:pPr>
+            <a:r>
+              <a:t>5 devs + 1 mgr</a:t>
+            </a:r>
+          </a:p>
+        </p:txBody>
+      </p:sp>
+      <p:sp>
+        <p:nvSpPr>
+          <p:cNvPr id="22" name="Rounded Rectangle 21"/>
+          <p:cNvSpPr/>
+          <p:nvPr/>
+        </p:nvSpPr>
+        <p:spPr>
+          <a:xfrm>
+            <a:off x="8705088" y="2240280"/>
+            <a:ext cx="3255264" cy="365760"/>
+          </a:xfrm>
+          <a:prstGeom prst="roundRect">
+            <a:avLst/>
+          </a:prstGeom>
+          <a:solidFill>
+            <a:srgbClr val="1565C0"/>
+          </a:solidFill>
+          <a:ln>
+            <a:noFill/>
+          </a:ln>
+        </p:spPr>
+        <p:style>
+          <a:lnRef idx="1">
+            <a:schemeClr val="accent1"/>
+          </a:lnRef>
+          <a:fillRef idx="3">
+            <a:schemeClr val="accent1"/>
+          </a:fillRef>
+          <a:effectRef idx="2">
+            <a:schemeClr val="accent1"/>
+          </a:effectRef>
+          <a:fontRef idx="minor">
+            <a:schemeClr val="lt1"/>
+          </a:fontRef>
+        </p:style>
+        <p:txBody>
+          <a:bodyPr rtlCol="0" anchor="ctr" lIns="36576" rIns="36576"/>
+          <a:lstStyle/>
+          <a:p>
+            <a:pPr algn="ctr">
+              <a:defRPr sz="800" b="1">
+                <a:solidFill>
+                  <a:srgbClr val="FFFFFF"/>
+                </a:solidFill>
+              </a:defRPr>
+            </a:pPr>
+            <a:r>
+              <a:t>6 devs + 1 mgr</a:t>
+            </a:r>
+          </a:p>
+        </p:txBody>
+      </p:sp>
+      <p:sp>
+        <p:nvSpPr>
+          <p:cNvPr id="23" name="TextBox 22"/>
+          <p:cNvSpPr txBox="1"/>
+          <p:nvPr/>
+        </p:nvSpPr>
+        <p:spPr>
+          <a:xfrm>
+            <a:off x="457200" y="2788920"/>
+            <a:ext cx="1645920" cy="274320"/>
+          </a:xfrm>
+          <a:prstGeom prst="rect">
+            <a:avLst/>
+          </a:prstGeom>
+          <a:noFill/>
+        </p:spPr>
+        <p:txBody>
+          <a:bodyPr wrap="none">
+            <a:spAutoFit/>
+          </a:bodyPr>
+          <a:lstStyle/>
+          <a:p>
+            <a:pPr>
+              <a:defRPr sz="1100" b="1">
+                <a:solidFill>
+                  <a:srgbClr val="1E1E1E"/>
+                </a:solidFill>
+              </a:defRPr>
+            </a:pPr>
+            <a:r>
+              <a:t>📊 Load vs capacity</a:t>
+            </a:r>
+          </a:p>
+        </p:txBody>
+      </p:sp>
+      <p:sp>
+        <p:nvSpPr>
+          <p:cNvPr id="24" name="Rounded Rectangle 23"/>
+          <p:cNvSpPr/>
+          <p:nvPr/>
+        </p:nvSpPr>
+        <p:spPr>
+          <a:xfrm>
+            <a:off x="2121408" y="2788920"/>
+            <a:ext cx="2157984" cy="502920"/>
+          </a:xfrm>
+          <a:prstGeom prst="roundRect">
+            <a:avLst/>
+          </a:prstGeom>
+          <a:solidFill>
+            <a:srgbClr val="2E7D32"/>
+          </a:solidFill>
+          <a:ln>
+            <a:noFill/>
+          </a:ln>
+        </p:spPr>
+        <p:style>
+          <a:lnRef idx="1">
+            <a:schemeClr val="accent1"/>
+          </a:lnRef>
+          <a:fillRef idx="3">
+            <a:schemeClr val="accent1"/>
+          </a:fillRef>
+          <a:effectRef idx="2">
+            <a:schemeClr val="accent1"/>
+          </a:effectRef>
+          <a:fontRef idx="minor">
+            <a:schemeClr val="lt1"/>
+          </a:fontRef>
+        </p:style>
+        <p:txBody>
+          <a:bodyPr rtlCol="0" anchor="ctr" wrap="square" lIns="27432" rIns="27432" tIns="18288"/>
+          <a:lstStyle/>
+          <a:p>
+            <a:pPr algn="ctr">
+              <a:defRPr sz="800" b="1">
+                <a:solidFill>
+                  <a:srgbClr val="FFFFFF"/>
+                </a:solidFill>
+              </a:defRPr>
+            </a:pPr>
+            <a:r>
+              <a:t>2.2 vs 3.5</a:t>
+            </a:r>
+          </a:p>
+          <a:p>
+            <a:pPr algn="ctr">
+              <a:defRPr sz="700" b="0">
+                <a:solidFill>
+                  <a:srgbClr val="FFFFFF"/>
+                </a:solidFill>
+              </a:defRPr>
+            </a:pPr>
+            <a:r>
+              <a:t>✅ OK</a:t>
+            </a:r>
+          </a:p>
+        </p:txBody>
+      </p:sp>
+      <p:sp>
+        <p:nvSpPr>
+          <p:cNvPr id="25" name="Rounded Rectangle 24"/>
+          <p:cNvSpPr/>
+          <p:nvPr/>
+        </p:nvSpPr>
+        <p:spPr>
+          <a:xfrm>
+            <a:off x="3218688" y="2788920"/>
+            <a:ext cx="1060704" cy="502920"/>
+          </a:xfrm>
+          <a:prstGeom prst="roundRect">
+            <a:avLst/>
+          </a:prstGeom>
+          <a:solidFill>
+            <a:srgbClr val="C62828"/>
+          </a:solidFill>
+          <a:ln>
+            <a:noFill/>
+          </a:ln>
+        </p:spPr>
+        <p:style>
+          <a:lnRef idx="1">
+            <a:schemeClr val="accent1"/>
+          </a:lnRef>
+          <a:fillRef idx="3">
+            <a:schemeClr val="accent1"/>
+          </a:fillRef>
+          <a:effectRef idx="2">
+            <a:schemeClr val="accent1"/>
+          </a:effectRef>
+          <a:fontRef idx="minor">
+            <a:schemeClr val="lt1"/>
+          </a:fontRef>
+        </p:style>
+        <p:txBody>
+          <a:bodyPr rtlCol="0" anchor="ctr" wrap="square" lIns="27432" rIns="27432" tIns="18288"/>
+          <a:lstStyle/>
+          <a:p>
+            <a:pPr algn="ctr">
+              <a:defRPr sz="800" b="1">
+                <a:solidFill>
+                  <a:srgbClr val="FFFFFF"/>
+                </a:solidFill>
+              </a:defRPr>
+            </a:pPr>
+            <a:r>
+              <a:t>6.0 vs 4.5</a:t>
+            </a:r>
+          </a:p>
+          <a:p>
+            <a:pPr algn="ctr">
+              <a:defRPr sz="700" b="0">
+                <a:solidFill>
+                  <a:srgbClr val="FFFFFF"/>
+                </a:solidFill>
+              </a:defRPr>
+            </a:pPr>
+            <a:r>
+              <a:t>🔴 TIGHT</a:t>
+            </a:r>
+          </a:p>
+        </p:txBody>
+      </p:sp>
+      <p:sp>
+        <p:nvSpPr>
+          <p:cNvPr id="26" name="Rounded Rectangle 25"/>
+          <p:cNvSpPr/>
+          <p:nvPr/>
+        </p:nvSpPr>
+        <p:spPr>
+          <a:xfrm>
+            <a:off x="4315968" y="2788920"/>
+            <a:ext cx="2157984" cy="502920"/>
+          </a:xfrm>
+          <a:prstGeom prst="roundRect">
+            <a:avLst/>
+          </a:prstGeom>
+          <a:solidFill>
+            <a:srgbClr val="2E7D32"/>
+          </a:solidFill>
+          <a:ln>
+            <a:noFill/>
+          </a:ln>
+        </p:spPr>
+        <p:style>
+          <a:lnRef idx="1">
+            <a:schemeClr val="accent1"/>
+          </a:lnRef>
+          <a:fillRef idx="3">
+            <a:schemeClr val="accent1"/>
+          </a:fillRef>
+          <a:effectRef idx="2">
+            <a:schemeClr val="accent1"/>
+          </a:effectRef>
+          <a:fontRef idx="minor">
+            <a:schemeClr val="lt1"/>
+          </a:fontRef>
+        </p:style>
+        <p:txBody>
+          <a:bodyPr rtlCol="0" anchor="ctr" wrap="square" lIns="27432" rIns="27432" tIns="18288"/>
+          <a:lstStyle/>
+          <a:p>
+            <a:pPr algn="ctr">
+              <a:defRPr sz="800" b="1">
+                <a:solidFill>
+                  <a:srgbClr val="FFFFFF"/>
+                </a:solidFill>
+              </a:defRPr>
+            </a:pPr>
+            <a:r>
+              <a:t>4.0 vs 4.5</a:t>
+            </a:r>
+          </a:p>
+          <a:p>
+            <a:pPr algn="ctr">
+              <a:defRPr sz="700" b="0">
+                <a:solidFill>
+                  <a:srgbClr val="FFFFFF"/>
+                </a:solidFill>
+              </a:defRPr>
+            </a:pPr>
+            <a:r>
+              <a:t>✅ Covered</a:t>
+            </a:r>
+          </a:p>
+        </p:txBody>
+      </p:sp>
+      <p:sp>
+        <p:nvSpPr>
+          <p:cNvPr id="27" name="Rounded Rectangle 26"/>
+          <p:cNvSpPr/>
+          <p:nvPr/>
+        </p:nvSpPr>
+        <p:spPr>
+          <a:xfrm>
+            <a:off x="6510528" y="2788920"/>
+            <a:ext cx="1060704" cy="502920"/>
+          </a:xfrm>
+          <a:prstGeom prst="roundRect">
+            <a:avLst/>
+          </a:prstGeom>
+          <a:solidFill>
+            <a:srgbClr val="2E7D32"/>
+          </a:solidFill>
+          <a:ln>
+            <a:noFill/>
+          </a:ln>
+        </p:spPr>
+        <p:style>
+          <a:lnRef idx="1">
+            <a:schemeClr val="accent1"/>
+          </a:lnRef>
+          <a:fillRef idx="3">
+            <a:schemeClr val="accent1"/>
+          </a:fillRef>
+          <a:effectRef idx="2">
+            <a:schemeClr val="accent1"/>
+          </a:effectRef>
+          <a:fontRef idx="minor">
+            <a:schemeClr val="lt1"/>
+          </a:fontRef>
+        </p:style>
+        <p:txBody>
+          <a:bodyPr rtlCol="0" anchor="ctr" wrap="square" lIns="27432" rIns="27432" tIns="18288"/>
+          <a:lstStyle/>
+          <a:p>
+            <a:pPr algn="ctr">
+              <a:defRPr sz="800" b="1">
+                <a:solidFill>
+                  <a:srgbClr val="FFFFFF"/>
+                </a:solidFill>
+              </a:defRPr>
+            </a:pPr>
+            <a:r>
+              <a:t>4.0 vs 5.5</a:t>
+            </a:r>
+          </a:p>
+          <a:p>
+            <a:pPr algn="ctr">
+              <a:defRPr sz="700" b="0">
+                <a:solidFill>
+                  <a:srgbClr val="FFFFFF"/>
+                </a:solidFill>
+              </a:defRPr>
+            </a:pPr>
+            <a:r>
+              <a:t>✅ Covered</a:t>
+            </a:r>
+          </a:p>
+        </p:txBody>
+      </p:sp>
+      <p:sp>
+        <p:nvSpPr>
+          <p:cNvPr id="28" name="Rounded Rectangle 27"/>
+          <p:cNvSpPr/>
+          <p:nvPr/>
+        </p:nvSpPr>
+        <p:spPr>
+          <a:xfrm>
+            <a:off x="7607808" y="2788920"/>
+            <a:ext cx="1060704" cy="502920"/>
+          </a:xfrm>
+          <a:prstGeom prst="roundRect">
+            <a:avLst/>
+          </a:prstGeom>
+          <a:solidFill>
+            <a:srgbClr val="F57C00"/>
+          </a:solidFill>
+          <a:ln>
+            <a:noFill/>
+          </a:ln>
+        </p:spPr>
+        <p:style>
+          <a:lnRef idx="1">
+            <a:schemeClr val="accent1"/>
+          </a:lnRef>
+          <a:fillRef idx="3">
+            <a:schemeClr val="accent1"/>
+          </a:fillRef>
+          <a:effectRef idx="2">
+            <a:schemeClr val="accent1"/>
+          </a:effectRef>
+          <a:fontRef idx="minor">
+            <a:schemeClr val="lt1"/>
+          </a:fontRef>
+        </p:style>
+        <p:txBody>
+          <a:bodyPr rtlCol="0" anchor="ctr" wrap="square" lIns="27432" rIns="27432" tIns="18288"/>
+          <a:lstStyle/>
+          <a:p>
+            <a:pPr algn="ctr">
+              <a:defRPr sz="800" b="1">
+                <a:solidFill>
+                  <a:srgbClr val="FFFFFF"/>
+                </a:solidFill>
+              </a:defRPr>
+            </a:pPr>
+            <a:r>
+              <a:t>5.0 vs 5.5</a:t>
+            </a:r>
+          </a:p>
+          <a:p>
+            <a:pPr algn="ctr">
+              <a:defRPr sz="700" b="0">
+                <a:solidFill>
+                  <a:srgbClr val="FFFFFF"/>
+                </a:solidFill>
+              </a:defRPr>
+            </a:pPr>
+            <a:r>
+              <a:t>⚠ Tight</a:t>
+            </a:r>
+          </a:p>
+        </p:txBody>
+      </p:sp>
+      <p:sp>
+        <p:nvSpPr>
+          <p:cNvPr id="29" name="Rounded Rectangle 28"/>
+          <p:cNvSpPr/>
+          <p:nvPr/>
+        </p:nvSpPr>
+        <p:spPr>
+          <a:xfrm>
+            <a:off x="8705088" y="2788920"/>
+            <a:ext cx="3255264" cy="502920"/>
+          </a:xfrm>
+          <a:prstGeom prst="roundRect">
+            <a:avLst/>
+          </a:prstGeom>
+          <a:solidFill>
+            <a:srgbClr val="1565C0"/>
+          </a:solidFill>
+          <a:ln>
+            <a:noFill/>
+          </a:ln>
+        </p:spPr>
+        <p:style>
+          <a:lnRef idx="1">
+            <a:schemeClr val="accent1"/>
+          </a:lnRef>
+          <a:fillRef idx="3">
+            <a:schemeClr val="accent1"/>
+          </a:fillRef>
+          <a:effectRef idx="2">
+            <a:schemeClr val="accent1"/>
+          </a:effectRef>
+          <a:fontRef idx="minor">
+            <a:schemeClr val="lt1"/>
+          </a:fontRef>
+        </p:style>
+        <p:txBody>
+          <a:bodyPr rtlCol="0" anchor="ctr" wrap="square" lIns="27432" rIns="27432" tIns="18288"/>
+          <a:lstStyle/>
+          <a:p>
+            <a:pPr algn="ctr">
+              <a:defRPr sz="800" b="1">
+                <a:solidFill>
+                  <a:srgbClr val="FFFFFF"/>
+                </a:solidFill>
+              </a:defRPr>
+            </a:pPr>
+            <a:r>
+              <a:t>3.5-4.0 vs 6.5</a:t>
+            </a:r>
+          </a:p>
+          <a:p>
+            <a:pPr algn="ctr">
+              <a:defRPr sz="700" b="0">
+                <a:solidFill>
+                  <a:srgbClr val="FFFFFF"/>
+                </a:solidFill>
+              </a:defRPr>
+            </a:pPr>
+            <a:r>
+              <a:t>✅ Comfortable</a:t>
+            </a:r>
+          </a:p>
+        </p:txBody>
+      </p:sp>
+      <p:sp>
+        <p:nvSpPr>
+          <p:cNvPr id="30" name="Rounded Rectangle 29"/>
+          <p:cNvSpPr/>
+          <p:nvPr/>
+        </p:nvSpPr>
+        <p:spPr>
+          <a:xfrm>
+            <a:off x="457200" y="3474720"/>
+            <a:ext cx="11247120" cy="3108960"/>
+          </a:xfrm>
+          <a:prstGeom prst="roundRect">
+            <a:avLst/>
+          </a:prstGeom>
+          <a:solidFill>
+            <a:srgbClr val="E8EAF6"/>
+          </a:solidFill>
+          <a:ln>
+            <a:noFill/>
+          </a:ln>
+        </p:spPr>
+        <p:style>
+          <a:lnRef idx="1">
+            <a:schemeClr val="accent1"/>
+          </a:lnRef>
+          <a:fillRef idx="3">
+            <a:schemeClr val="accent1"/>
+          </a:fillRef>
+          <a:effectRef idx="2">
+            <a:schemeClr val="accent1"/>
+          </a:effectRef>
+          <a:fontRef idx="minor">
+            <a:schemeClr val="lt1"/>
+          </a:fontRef>
+        </p:style>
+        <p:txBody>
+          <a:bodyPr rtlCol="0" anchor="ctr" wrap="square" lIns="182880" rIns="182880" tIns="137160" bIns="137160"/>
+          <a:lstStyle/>
+          <a:p>
+            <a:pPr algn="ctr">
+              <a:spcAft>
+                <a:spcPts val="600"/>
+              </a:spcAft>
+              <a:defRPr sz="1400" b="1">
+                <a:solidFill>
+                  <a:srgbClr val="1A237E"/>
+                </a:solidFill>
+              </a:defRPr>
+            </a:pPr>
+            <a:r>
+              <a:t>Why These 3 Hires, Why These Dates</a:t>
+            </a:r>
+          </a:p>
+          <a:p>
+            <a:pPr>
+              <a:spcAft>
+                <a:spcPts val="400"/>
+              </a:spcAft>
+              <a:defRPr sz="1000">
+                <a:solidFill>
+                  <a:srgbClr val="1E1E1E"/>
+                </a:solidFill>
+              </a:defRPr>
+            </a:pPr>
+            <a:r>
+              <a:rPr sz="1000" b="1">
+                <a:solidFill>
+                  <a:srgbClr val="1A237E"/>
+                </a:solidFill>
+              </a:rPr>
+              <a:t>Hire #1 — Sep 2026: </a:t>
+            </a:r>
+            <a:r>
+              <a:rPr sz="1000">
+                <a:solidFill>
+                  <a:srgbClr val="1E1E1E"/>
+                </a:solidFill>
+              </a:rPr>
+              <a:t>26H2 is the cliff. 9 concurrent projects spike dev-load to 6.0. Without this hire, PLAT-01 or APP-SEP-01 will stall. This hire absorbs reservation/knowledge platform work, freeing senior devs for architecture.</a:t>
+            </a:r>
+          </a:p>
+          <a:p>
+            <a:pPr>
+              <a:spcAft>
+                <a:spcPts val="400"/>
+              </a:spcAft>
+              <a:defRPr sz="1000">
+                <a:solidFill>
+                  <a:srgbClr val="1E1E1E"/>
+                </a:solidFill>
+              </a:defRPr>
+            </a:pPr>
+            <a:r>
+              <a:rPr sz="1000" b="1">
+                <a:solidFill>
+                  <a:srgbClr val="1A237E"/>
+                </a:solidFill>
+              </a:rPr>
+              <a:t>Hire #2 — Apr 2027: </a:t>
+            </a:r>
+            <a:r>
+              <a:rPr sz="1000">
+                <a:solidFill>
+                  <a:srgbClr val="1E1E1E"/>
+                </a:solidFill>
+              </a:rPr>
+              <a:t>27H1 has 3 heavy projects + DEVAI-01 ramping up. Second hire absorbs governance/staff-builder support so existing devs stay focused on backend separation.</a:t>
+            </a:r>
+          </a:p>
+          <a:p>
+            <a:pPr>
+              <a:spcAft>
+                <a:spcPts val="400"/>
+              </a:spcAft>
+              <a:defRPr sz="1000">
+                <a:solidFill>
+                  <a:srgbClr val="1E1E1E"/>
+                </a:solidFill>
+              </a:defRPr>
+            </a:pPr>
+            <a:r>
+              <a:rPr sz="1000" b="1">
+                <a:solidFill>
+                  <a:srgbClr val="1A237E"/>
+                </a:solidFill>
+              </a:rPr>
+              <a:t>Hire #3 — Jan 2028: </a:t>
+            </a:r>
+            <a:r>
+              <a:rPr sz="1000">
+                <a:solidFill>
+                  <a:srgbClr val="1E1E1E"/>
+                </a:solidFill>
+              </a:rPr>
+              <a:t>28H2 adds TENANT-01 and BOHRCORP-01 on top of ongoing PLAT-01 + APP-SEP-01. Dev-load hits 5.0. Third hire takes on SaaS foundation.</a:t>
+            </a:r>
+          </a:p>
+          <a:p>
+            <a:pPr>
+              <a:spcBef>
+                <a:spcPts val="400"/>
+              </a:spcBef>
+            </a:pPr>
+          </a:p>
+          <a:p>
+            <a:r>
+              <a:rPr sz="1000" b="1">
+                <a:solidFill>
+                  <a:srgbClr val="2E7D32"/>
+                </a:solidFill>
+              </a:rPr>
+              <a:t>What to look for: </a:t>
+            </a:r>
+            <a:r>
+              <a:rPr sz="1000">
+                <a:solidFill>
+                  <a:srgbClr val="1E1E1E"/>
+                </a:solidFill>
+              </a:rPr>
+              <a:t>Solid dev fundamentals (read code, debug, tests) · Git/PR literacy · Communication skills · Full-stack (Django/Go + Vue) · 2-4 years experience · Independent after 2-month ramp</a:t>
+            </a:r>
+          </a:p>
+          <a:p>
+            <a:r>
+              <a:rPr sz="1000" b="1">
+                <a:solidFill>
+                  <a:srgbClr val="C62828"/>
+                </a:solidFill>
+              </a:rPr>
+              <a:t>What's NOT required: </a:t>
+            </a:r>
+            <a:r>
+              <a:rPr sz="1000">
+                <a:solidFill>
+                  <a:srgbClr val="1E1E1E"/>
+                </a:solidFill>
+              </a:rPr>
+              <a:t>AI/ML expertise (building in-house) · Kubernetes/microservices (ARCH-01 defines) · SaaS platform experience (TENANT-01 is greenfield) · Senior architect-level (manager sets architecture)</a:t>
+            </a:r>
+          </a:p>
+          <a:p>
+            <a:pPr>
+              <a:spcBef>
+                <a:spcPts val="400"/>
+              </a:spcBef>
+            </a:pPr>
+          </a:p>
+          <a:p>
+            <a:r>
+              <a:rPr sz="1000" b="1">
+                <a:solidFill>
+                  <a:srgbClr val="1A237E"/>
+                </a:solidFill>
+              </a:rPr>
+              <a:t>Why 1-at-a-time: </a:t>
+            </a:r>
+            <a:r>
+              <a:rPr sz="1000">
+                <a:solidFill>
+                  <a:srgbClr val="1E1E1E"/>
+                </a:solidFill>
+              </a:rPr>
+              <a:t>Manager does most training. Each hire needs ~2 months ramp-up. Staggering matches the schedule's ramp-up pattern and prevents training overload.</a:t>
             </a:r>
           </a:p>
         </p:txBody>

</xml_diff>

<commit_message>
Hiring plan: plain language wording, manager excluded from dev capacity, 4 project starts pushed Dec→Jan to match hiring pace
</commit_message>
<xml_diff>
--- a/ia-strategy-visual.pptx
+++ b/ia-strategy-visual.pptx
@@ -11,7 +11,7 @@
     <p:sldId id="259" r:id="rId10"/>
     <p:sldId id="260" r:id="rId11"/>
     <p:sldId id="261" r:id="rId12"/>
-    <p:sldId id="262" r:id="rId13"/>
+    <p:sldId id="262" r:id="rId14"/>
   </p:sldIdLst>
   <p:sldSz cx="12191695" cy="6858000" type="screen4x3"/>
   <p:notesSz cx="6858000" cy="9144000"/>
@@ -19636,7 +19636,7 @@
         <p:spPr>
           <a:xfrm>
             <a:off x="457200" y="685800"/>
-            <a:ext cx="10972800" cy="274320"/>
+            <a:ext cx="11247120" cy="320040"/>
           </a:xfrm>
           <a:prstGeom prst="rect">
             <a:avLst/>
@@ -19650,14 +19650,14 @@
           <a:lstStyle/>
           <a:p>
             <a:pPr>
-              <a:defRPr sz="1200">
+              <a:defRPr sz="1100">
                 <a:solidFill>
                   <a:srgbClr val="616161"/>
                 </a:solidFill>
               </a:defRPr>
             </a:pPr>
             <a:r>
-              <a:t>Staffing Timeline — 3 Hires Staggered Across 18 Months (Current: 3 devs + 1 mgr → Target: 6 devs + 1 mgr)</a:t>
+              <a:t>Current: 3 developers + 1 manager (training/management). Target: 6 developers. 4 project starts pushed from Dec 2026 → Jan 2027 to match hiring pace.</a:t>
             </a:r>
           </a:p>
         </p:txBody>
@@ -19670,7 +19670,7 @@
         </p:nvSpPr>
         <p:spPr>
           <a:xfrm>
-            <a:off x="2103120" y="1051560"/>
+            <a:off x="2103120" y="1097280"/>
             <a:ext cx="1097280" cy="320040"/>
           </a:xfrm>
           <a:prstGeom prst="rect">
@@ -19705,7 +19705,7 @@
         </p:nvSpPr>
         <p:spPr>
           <a:xfrm>
-            <a:off x="3200400" y="1051560"/>
+            <a:off x="3200400" y="1097280"/>
             <a:ext cx="1097280" cy="320040"/>
           </a:xfrm>
           <a:prstGeom prst="rect">
@@ -19740,7 +19740,7 @@
         </p:nvSpPr>
         <p:spPr>
           <a:xfrm>
-            <a:off x="4297680" y="1051560"/>
+            <a:off x="4297680" y="1097280"/>
             <a:ext cx="1097280" cy="320040"/>
           </a:xfrm>
           <a:prstGeom prst="rect">
@@ -19775,7 +19775,7 @@
         </p:nvSpPr>
         <p:spPr>
           <a:xfrm>
-            <a:off x="5394960" y="1051560"/>
+            <a:off x="5394960" y="1097280"/>
             <a:ext cx="1097280" cy="320040"/>
           </a:xfrm>
           <a:prstGeom prst="rect">
@@ -19810,7 +19810,7 @@
         </p:nvSpPr>
         <p:spPr>
           <a:xfrm>
-            <a:off x="6492240" y="1051560"/>
+            <a:off x="6492240" y="1097280"/>
             <a:ext cx="1097280" cy="320040"/>
           </a:xfrm>
           <a:prstGeom prst="rect">
@@ -19845,7 +19845,7 @@
         </p:nvSpPr>
         <p:spPr>
           <a:xfrm>
-            <a:off x="7589520" y="1051560"/>
+            <a:off x="7589520" y="1097280"/>
             <a:ext cx="1097280" cy="320040"/>
           </a:xfrm>
           <a:prstGeom prst="rect">
@@ -19880,7 +19880,7 @@
         </p:nvSpPr>
         <p:spPr>
           <a:xfrm>
-            <a:off x="8686800" y="1051560"/>
+            <a:off x="8686800" y="1097280"/>
             <a:ext cx="1097280" cy="320040"/>
           </a:xfrm>
           <a:prstGeom prst="rect">
@@ -19915,7 +19915,7 @@
         </p:nvSpPr>
         <p:spPr>
           <a:xfrm>
-            <a:off x="9784080" y="1051560"/>
+            <a:off x="9784080" y="1097280"/>
             <a:ext cx="1097280" cy="320040"/>
           </a:xfrm>
           <a:prstGeom prst="rect">
@@ -19950,7 +19950,7 @@
         </p:nvSpPr>
         <p:spPr>
           <a:xfrm>
-            <a:off x="10881360" y="1051560"/>
+            <a:off x="10881360" y="1097280"/>
             <a:ext cx="1097280" cy="320040"/>
           </a:xfrm>
           <a:prstGeom prst="rect">
@@ -19985,7 +19985,7 @@
         </p:nvSpPr>
         <p:spPr>
           <a:xfrm>
-            <a:off x="457200" y="1508760"/>
+            <a:off x="457200" y="1554480"/>
             <a:ext cx="1645920" cy="274320"/>
           </a:xfrm>
           <a:prstGeom prst="rect">
@@ -20007,7 +20007,7 @@
               </a:defRPr>
             </a:pPr>
             <a:r>
-              <a:t>📅 Hires</a:t>
+              <a:t>📅 New hires</a:t>
             </a:r>
           </a:p>
         </p:txBody>
@@ -20020,7 +20020,7 @@
         </p:nvSpPr>
         <p:spPr>
           <a:xfrm>
-            <a:off x="3218688" y="1508760"/>
+            <a:off x="3218688" y="1554480"/>
             <a:ext cx="1060704" cy="548640"/>
           </a:xfrm>
           <a:prstGeom prst="roundRect">
@@ -20048,7 +20048,7 @@
           </a:fontRef>
         </p:style>
         <p:txBody>
-          <a:bodyPr rtlCol="0" anchor="ctr" wrap="square" lIns="36576" rIns="36576" tIns="18288" bIns="18288"/>
+          <a:bodyPr rtlCol="0" anchor="ctr" wrap="square" tIns="18288"/>
           <a:lstStyle/>
           <a:p>
             <a:pPr algn="ctr">
@@ -20064,7 +20064,7 @@
           </a:p>
           <a:p>
             <a:pPr algn="ctr">
-              <a:defRPr sz="900" b="1">
+              <a:defRPr sz="1000" b="1">
                 <a:solidFill>
                   <a:srgbClr val="FFFFFF"/>
                 </a:solidFill>
@@ -20084,7 +20084,7 @@
         </p:nvSpPr>
         <p:spPr>
           <a:xfrm>
-            <a:off x="4315968" y="1508760"/>
+            <a:off x="4315968" y="1554480"/>
             <a:ext cx="1060704" cy="548640"/>
           </a:xfrm>
           <a:prstGeom prst="roundRect">
@@ -20112,7 +20112,7 @@
           </a:fontRef>
         </p:style>
         <p:txBody>
-          <a:bodyPr rtlCol="0" anchor="ctr" wrap="square" lIns="36576" rIns="36576" tIns="18288" bIns="18288"/>
+          <a:bodyPr rtlCol="0" anchor="ctr" wrap="square" tIns="18288"/>
           <a:lstStyle/>
           <a:p>
             <a:pPr algn="ctr">
@@ -20128,7 +20128,7 @@
           </a:p>
           <a:p>
             <a:pPr algn="ctr">
-              <a:defRPr sz="900" b="1">
+              <a:defRPr sz="1000" b="1">
                 <a:solidFill>
                   <a:srgbClr val="FFFFFF"/>
                 </a:solidFill>
@@ -20148,7 +20148,7 @@
         </p:nvSpPr>
         <p:spPr>
           <a:xfrm>
-            <a:off x="6510528" y="1508760"/>
+            <a:off x="6510528" y="1554480"/>
             <a:ext cx="1060704" cy="548640"/>
           </a:xfrm>
           <a:prstGeom prst="roundRect">
@@ -20176,7 +20176,7 @@
           </a:fontRef>
         </p:style>
         <p:txBody>
-          <a:bodyPr rtlCol="0" anchor="ctr" wrap="square" lIns="36576" rIns="36576" tIns="18288" bIns="18288"/>
+          <a:bodyPr rtlCol="0" anchor="ctr" wrap="square" tIns="18288"/>
           <a:lstStyle/>
           <a:p>
             <a:pPr algn="ctr">
@@ -20192,7 +20192,7 @@
           </a:p>
           <a:p>
             <a:pPr algn="ctr">
-              <a:defRPr sz="900" b="1">
+              <a:defRPr sz="1000" b="1">
                 <a:solidFill>
                   <a:srgbClr val="FFFFFF"/>
                 </a:solidFill>
@@ -20212,7 +20212,7 @@
         </p:nvSpPr>
         <p:spPr>
           <a:xfrm>
-            <a:off x="457200" y="2240280"/>
+            <a:off x="457200" y="2286000"/>
             <a:ext cx="1645920" cy="274320"/>
           </a:xfrm>
           <a:prstGeom prst="rect">
@@ -20247,7 +20247,7 @@
         </p:nvSpPr>
         <p:spPr>
           <a:xfrm>
-            <a:off x="2121408" y="2240280"/>
+            <a:off x="2121408" y="2286000"/>
             <a:ext cx="2157984" cy="365760"/>
           </a:xfrm>
           <a:prstGeom prst="roundRect">
@@ -20275,18 +20275,18 @@
           </a:fontRef>
         </p:style>
         <p:txBody>
-          <a:bodyPr rtlCol="0" anchor="ctr" lIns="36576" rIns="36576"/>
-          <a:lstStyle/>
-          <a:p>
-            <a:pPr algn="ctr">
-              <a:defRPr sz="800" b="1">
+          <a:bodyPr rtlCol="0" anchor="ctr" lIns="36576"/>
+          <a:lstStyle/>
+          <a:p>
+            <a:pPr algn="ctr">
+              <a:defRPr sz="900" b="1">
                 <a:solidFill>
                   <a:srgbClr val="FFFFFF"/>
                 </a:solidFill>
               </a:defRPr>
             </a:pPr>
             <a:r>
-              <a:t>3 devs + 1 mgr</a:t>
+              <a:t>3 developers</a:t>
             </a:r>
           </a:p>
         </p:txBody>
@@ -20299,7 +20299,7 @@
         </p:nvSpPr>
         <p:spPr>
           <a:xfrm>
-            <a:off x="4315968" y="2240280"/>
+            <a:off x="4315968" y="2286000"/>
             <a:ext cx="2157984" cy="365760"/>
           </a:xfrm>
           <a:prstGeom prst="roundRect">
@@ -20327,18 +20327,18 @@
           </a:fontRef>
         </p:style>
         <p:txBody>
-          <a:bodyPr rtlCol="0" anchor="ctr" lIns="36576" rIns="36576"/>
-          <a:lstStyle/>
-          <a:p>
-            <a:pPr algn="ctr">
-              <a:defRPr sz="800" b="1">
+          <a:bodyPr rtlCol="0" anchor="ctr" lIns="36576"/>
+          <a:lstStyle/>
+          <a:p>
+            <a:pPr algn="ctr">
+              <a:defRPr sz="900" b="1">
                 <a:solidFill>
                   <a:srgbClr val="FFFFFF"/>
                 </a:solidFill>
               </a:defRPr>
             </a:pPr>
             <a:r>
-              <a:t>4 devs + 1 mgr</a:t>
+              <a:t>4 developers</a:t>
             </a:r>
           </a:p>
         </p:txBody>
@@ -20351,7 +20351,7 @@
         </p:nvSpPr>
         <p:spPr>
           <a:xfrm>
-            <a:off x="6510528" y="2240280"/>
+            <a:off x="6510528" y="2286000"/>
             <a:ext cx="2157984" cy="365760"/>
           </a:xfrm>
           <a:prstGeom prst="roundRect">
@@ -20379,18 +20379,18 @@
           </a:fontRef>
         </p:style>
         <p:txBody>
-          <a:bodyPr rtlCol="0" anchor="ctr" lIns="36576" rIns="36576"/>
-          <a:lstStyle/>
-          <a:p>
-            <a:pPr algn="ctr">
-              <a:defRPr sz="800" b="1">
+          <a:bodyPr rtlCol="0" anchor="ctr" lIns="36576"/>
+          <a:lstStyle/>
+          <a:p>
+            <a:pPr algn="ctr">
+              <a:defRPr sz="900" b="1">
                 <a:solidFill>
                   <a:srgbClr val="FFFFFF"/>
                 </a:solidFill>
               </a:defRPr>
             </a:pPr>
             <a:r>
-              <a:t>5 devs + 1 mgr</a:t>
+              <a:t>5 developers</a:t>
             </a:r>
           </a:p>
         </p:txBody>
@@ -20403,7 +20403,7 @@
         </p:nvSpPr>
         <p:spPr>
           <a:xfrm>
-            <a:off x="8705088" y="2240280"/>
+            <a:off x="8705088" y="2286000"/>
             <a:ext cx="3255264" cy="365760"/>
           </a:xfrm>
           <a:prstGeom prst="roundRect">
@@ -20431,18 +20431,18 @@
           </a:fontRef>
         </p:style>
         <p:txBody>
-          <a:bodyPr rtlCol="0" anchor="ctr" lIns="36576" rIns="36576"/>
-          <a:lstStyle/>
-          <a:p>
-            <a:pPr algn="ctr">
-              <a:defRPr sz="800" b="1">
+          <a:bodyPr rtlCol="0" anchor="ctr" lIns="36576"/>
+          <a:lstStyle/>
+          <a:p>
+            <a:pPr algn="ctr">
+              <a:defRPr sz="900" b="1">
                 <a:solidFill>
                   <a:srgbClr val="FFFFFF"/>
                 </a:solidFill>
               </a:defRPr>
             </a:pPr>
             <a:r>
-              <a:t>6 devs + 1 mgr</a:t>
+              <a:t>6 developers</a:t>
             </a:r>
           </a:p>
         </p:txBody>
@@ -20455,7 +20455,7 @@
         </p:nvSpPr>
         <p:spPr>
           <a:xfrm>
-            <a:off x="457200" y="2788920"/>
+            <a:off x="457200" y="2834640"/>
             <a:ext cx="1645920" cy="274320"/>
           </a:xfrm>
           <a:prstGeom prst="rect">
@@ -20477,7 +20477,7 @@
               </a:defRPr>
             </a:pPr>
             <a:r>
-              <a:t>📊 Load vs capacity</a:t>
+              <a:t>📊 Workload vs team</a:t>
             </a:r>
           </a:p>
         </p:txBody>
@@ -20490,7 +20490,7 @@
         </p:nvSpPr>
         <p:spPr>
           <a:xfrm>
-            <a:off x="2121408" y="2788920"/>
+            <a:off x="2121408" y="2834640"/>
             <a:ext cx="2157984" cy="502920"/>
           </a:xfrm>
           <a:prstGeom prst="roundRect">
@@ -20518,18 +20518,18 @@
           </a:fontRef>
         </p:style>
         <p:txBody>
-          <a:bodyPr rtlCol="0" anchor="ctr" wrap="square" lIns="27432" rIns="27432" tIns="18288"/>
-          <a:lstStyle/>
-          <a:p>
-            <a:pPr algn="ctr">
-              <a:defRPr sz="800" b="1">
+          <a:bodyPr rtlCol="0" anchor="ctr" wrap="square" tIns="18288"/>
+          <a:lstStyle/>
+          <a:p>
+            <a:pPr algn="ctr">
+              <a:defRPr sz="700" b="1">
                 <a:solidFill>
                   <a:srgbClr val="FFFFFF"/>
                 </a:solidFill>
               </a:defRPr>
             </a:pPr>
             <a:r>
-              <a:t>2.2 vs 3.5</a:t>
+              <a:t>Need ~2, have 3</a:t>
             </a:r>
           </a:p>
           <a:p>
@@ -20554,46 +20554,46 @@
         </p:nvSpPr>
         <p:spPr>
           <a:xfrm>
-            <a:off x="3218688" y="2788920"/>
+            <a:off x="3218688" y="2834640"/>
             <a:ext cx="1060704" cy="502920"/>
           </a:xfrm>
           <a:prstGeom prst="roundRect">
             <a:avLst/>
           </a:prstGeom>
           <a:solidFill>
-            <a:srgbClr val="C62828"/>
-          </a:solidFill>
-          <a:ln>
-            <a:noFill/>
-          </a:ln>
-        </p:spPr>
-        <p:style>
-          <a:lnRef idx="1">
-            <a:schemeClr val="accent1"/>
-          </a:lnRef>
-          <a:fillRef idx="3">
-            <a:schemeClr val="accent1"/>
-          </a:fillRef>
-          <a:effectRef idx="2">
-            <a:schemeClr val="accent1"/>
-          </a:effectRef>
-          <a:fontRef idx="minor">
-            <a:schemeClr val="lt1"/>
-          </a:fontRef>
-        </p:style>
-        <p:txBody>
-          <a:bodyPr rtlCol="0" anchor="ctr" wrap="square" lIns="27432" rIns="27432" tIns="18288"/>
-          <a:lstStyle/>
-          <a:p>
-            <a:pPr algn="ctr">
-              <a:defRPr sz="800" b="1">
+            <a:srgbClr val="2E7D32"/>
+          </a:solidFill>
+          <a:ln>
+            <a:noFill/>
+          </a:ln>
+        </p:spPr>
+        <p:style>
+          <a:lnRef idx="1">
+            <a:schemeClr val="accent1"/>
+          </a:lnRef>
+          <a:fillRef idx="3">
+            <a:schemeClr val="accent1"/>
+          </a:fillRef>
+          <a:effectRef idx="2">
+            <a:schemeClr val="accent1"/>
+          </a:effectRef>
+          <a:fontRef idx="minor">
+            <a:schemeClr val="lt1"/>
+          </a:fontRef>
+        </p:style>
+        <p:txBody>
+          <a:bodyPr rtlCol="0" anchor="ctr" wrap="square" tIns="18288"/>
+          <a:lstStyle/>
+          <a:p>
+            <a:pPr algn="ctr">
+              <a:defRPr sz="700" b="1">
                 <a:solidFill>
                   <a:srgbClr val="FFFFFF"/>
                 </a:solidFill>
               </a:defRPr>
             </a:pPr>
             <a:r>
-              <a:t>6.0 vs 4.5</a:t>
+              <a:t>Need ~3, have 3+1ᵃ</a:t>
             </a:r>
           </a:p>
           <a:p>
@@ -20605,7 +20605,7 @@
               </a:defRPr>
             </a:pPr>
             <a:r>
-              <a:t>🔴 TIGHT</a:t>
+              <a:t>✅ OK (ramping)</a:t>
             </a:r>
           </a:p>
         </p:txBody>
@@ -20618,7 +20618,7 @@
         </p:nvSpPr>
         <p:spPr>
           <a:xfrm>
-            <a:off x="4315968" y="2788920"/>
+            <a:off x="4315968" y="2834640"/>
             <a:ext cx="2157984" cy="502920"/>
           </a:xfrm>
           <a:prstGeom prst="roundRect">
@@ -20646,18 +20646,18 @@
           </a:fontRef>
         </p:style>
         <p:txBody>
-          <a:bodyPr rtlCol="0" anchor="ctr" wrap="square" lIns="27432" rIns="27432" tIns="18288"/>
-          <a:lstStyle/>
-          <a:p>
-            <a:pPr algn="ctr">
-              <a:defRPr sz="800" b="1">
+          <a:bodyPr rtlCol="0" anchor="ctr" wrap="square" tIns="18288"/>
+          <a:lstStyle/>
+          <a:p>
+            <a:pPr algn="ctr">
+              <a:defRPr sz="700" b="1">
                 <a:solidFill>
                   <a:srgbClr val="FFFFFF"/>
                 </a:solidFill>
               </a:defRPr>
             </a:pPr>
             <a:r>
-              <a:t>4.0 vs 4.5</a:t>
+              <a:t>Need ~4, have 4</a:t>
             </a:r>
           </a:p>
           <a:p>
@@ -20682,7 +20682,7 @@
         </p:nvSpPr>
         <p:spPr>
           <a:xfrm>
-            <a:off x="6510528" y="2788920"/>
+            <a:off x="5413248" y="2834640"/>
             <a:ext cx="1060704" cy="502920"/>
           </a:xfrm>
           <a:prstGeom prst="roundRect">
@@ -20710,18 +20710,18 @@
           </a:fontRef>
         </p:style>
         <p:txBody>
-          <a:bodyPr rtlCol="0" anchor="ctr" wrap="square" lIns="27432" rIns="27432" tIns="18288"/>
-          <a:lstStyle/>
-          <a:p>
-            <a:pPr algn="ctr">
-              <a:defRPr sz="800" b="1">
+          <a:bodyPr rtlCol="0" anchor="ctr" wrap="square" tIns="18288"/>
+          <a:lstStyle/>
+          <a:p>
+            <a:pPr algn="ctr">
+              <a:defRPr sz="700" b="1">
                 <a:solidFill>
                   <a:srgbClr val="FFFFFF"/>
                 </a:solidFill>
               </a:defRPr>
             </a:pPr>
             <a:r>
-              <a:t>4.0 vs 5.5</a:t>
+              <a:t>Need ~3, have 4</a:t>
             </a:r>
           </a:p>
           <a:p>
@@ -20733,6 +20733,70 @@
               </a:defRPr>
             </a:pPr>
             <a:r>
+              <a:t>✅ Comfortable</a:t>
+            </a:r>
+          </a:p>
+        </p:txBody>
+      </p:sp>
+      <p:sp>
+        <p:nvSpPr>
+          <p:cNvPr id="28" name="Rounded Rectangle 27"/>
+          <p:cNvSpPr/>
+          <p:nvPr/>
+        </p:nvSpPr>
+        <p:spPr>
+          <a:xfrm>
+            <a:off x="6510528" y="2834640"/>
+            <a:ext cx="1060704" cy="502920"/>
+          </a:xfrm>
+          <a:prstGeom prst="roundRect">
+            <a:avLst/>
+          </a:prstGeom>
+          <a:solidFill>
+            <a:srgbClr val="2E7D32"/>
+          </a:solidFill>
+          <a:ln>
+            <a:noFill/>
+          </a:ln>
+        </p:spPr>
+        <p:style>
+          <a:lnRef idx="1">
+            <a:schemeClr val="accent1"/>
+          </a:lnRef>
+          <a:fillRef idx="3">
+            <a:schemeClr val="accent1"/>
+          </a:fillRef>
+          <a:effectRef idx="2">
+            <a:schemeClr val="accent1"/>
+          </a:effectRef>
+          <a:fontRef idx="minor">
+            <a:schemeClr val="lt1"/>
+          </a:fontRef>
+        </p:style>
+        <p:txBody>
+          <a:bodyPr rtlCol="0" anchor="ctr" wrap="square" tIns="18288"/>
+          <a:lstStyle/>
+          <a:p>
+            <a:pPr algn="ctr">
+              <a:defRPr sz="700" b="1">
+                <a:solidFill>
+                  <a:srgbClr val="FFFFFF"/>
+                </a:solidFill>
+              </a:defRPr>
+            </a:pPr>
+            <a:r>
+              <a:t>Need ~4, have 5</a:t>
+            </a:r>
+          </a:p>
+          <a:p>
+            <a:pPr algn="ctr">
+              <a:defRPr sz="700" b="0">
+                <a:solidFill>
+                  <a:srgbClr val="FFFFFF"/>
+                </a:solidFill>
+              </a:defRPr>
+            </a:pPr>
+            <a:r>
               <a:t>✅ Covered</a:t>
             </a:r>
           </a:p>
@@ -20740,13 +20804,13 @@
       </p:sp>
       <p:sp>
         <p:nvSpPr>
-          <p:cNvPr id="28" name="Rounded Rectangle 27"/>
-          <p:cNvSpPr/>
-          <p:nvPr/>
-        </p:nvSpPr>
-        <p:spPr>
-          <a:xfrm>
-            <a:off x="7607808" y="2788920"/>
+          <p:cNvPr id="29" name="Rounded Rectangle 28"/>
+          <p:cNvSpPr/>
+          <p:nvPr/>
+        </p:nvSpPr>
+        <p:spPr>
+          <a:xfrm>
+            <a:off x="7607808" y="2834640"/>
             <a:ext cx="1060704" cy="502920"/>
           </a:xfrm>
           <a:prstGeom prst="roundRect">
@@ -20774,18 +20838,18 @@
           </a:fontRef>
         </p:style>
         <p:txBody>
-          <a:bodyPr rtlCol="0" anchor="ctr" wrap="square" lIns="27432" rIns="27432" tIns="18288"/>
-          <a:lstStyle/>
-          <a:p>
-            <a:pPr algn="ctr">
-              <a:defRPr sz="800" b="1">
+          <a:bodyPr rtlCol="0" anchor="ctr" wrap="square" tIns="18288"/>
+          <a:lstStyle/>
+          <a:p>
+            <a:pPr algn="ctr">
+              <a:defRPr sz="700" b="1">
                 <a:solidFill>
                   <a:srgbClr val="FFFFFF"/>
                 </a:solidFill>
               </a:defRPr>
             </a:pPr>
             <a:r>
-              <a:t>5.0 vs 5.5</a:t>
+              <a:t>Need ~5, have 5</a:t>
             </a:r>
           </a:p>
           <a:p>
@@ -20804,13 +20868,13 @@
       </p:sp>
       <p:sp>
         <p:nvSpPr>
-          <p:cNvPr id="29" name="Rounded Rectangle 28"/>
-          <p:cNvSpPr/>
-          <p:nvPr/>
-        </p:nvSpPr>
-        <p:spPr>
-          <a:xfrm>
-            <a:off x="8705088" y="2788920"/>
+          <p:cNvPr id="30" name="Rounded Rectangle 29"/>
+          <p:cNvSpPr/>
+          <p:nvPr/>
+        </p:nvSpPr>
+        <p:spPr>
+          <a:xfrm>
+            <a:off x="8705088" y="2834640"/>
             <a:ext cx="3255264" cy="502920"/>
           </a:xfrm>
           <a:prstGeom prst="roundRect">
@@ -20838,18 +20902,18 @@
           </a:fontRef>
         </p:style>
         <p:txBody>
-          <a:bodyPr rtlCol="0" anchor="ctr" wrap="square" lIns="27432" rIns="27432" tIns="18288"/>
-          <a:lstStyle/>
-          <a:p>
-            <a:pPr algn="ctr">
-              <a:defRPr sz="800" b="1">
+          <a:bodyPr rtlCol="0" anchor="ctr" wrap="square" tIns="18288"/>
+          <a:lstStyle/>
+          <a:p>
+            <a:pPr algn="ctr">
+              <a:defRPr sz="700" b="1">
                 <a:solidFill>
                   <a:srgbClr val="FFFFFF"/>
                 </a:solidFill>
               </a:defRPr>
             </a:pPr>
             <a:r>
-              <a:t>3.5-4.0 vs 6.5</a:t>
+              <a:t>Need ~4, have 6</a:t>
             </a:r>
           </a:p>
           <a:p>
@@ -20868,14 +20932,14 @@
       </p:sp>
       <p:sp>
         <p:nvSpPr>
-          <p:cNvPr id="30" name="Rounded Rectangle 29"/>
-          <p:cNvSpPr/>
-          <p:nvPr/>
-        </p:nvSpPr>
-        <p:spPr>
-          <a:xfrm>
-            <a:off x="457200" y="3474720"/>
-            <a:ext cx="11247120" cy="3108960"/>
+          <p:cNvPr id="31" name="Rounded Rectangle 30"/>
+          <p:cNvSpPr/>
+          <p:nvPr/>
+        </p:nvSpPr>
+        <p:spPr>
+          <a:xfrm>
+            <a:off x="457200" y="3520440"/>
+            <a:ext cx="11247120" cy="3063240"/>
           </a:xfrm>
           <a:prstGeom prst="roundRect">
             <a:avLst/>
@@ -20902,7 +20966,7 @@
           </a:fontRef>
         </p:style>
         <p:txBody>
-          <a:bodyPr rtlCol="0" anchor="ctr" wrap="square" lIns="182880" rIns="182880" tIns="137160" bIns="137160"/>
+          <a:bodyPr rtlCol="0" anchor="ctr" wrap="square" lIns="182880" rIns="182880" tIns="137160"/>
           <a:lstStyle/>
           <a:p>
             <a:pPr algn="ctr">
@@ -20924,11 +20988,6 @@
               <a:spcAft>
                 <a:spcPts val="400"/>
               </a:spcAft>
-              <a:defRPr sz="1000">
-                <a:solidFill>
-                  <a:srgbClr val="1E1E1E"/>
-                </a:solidFill>
-              </a:defRPr>
             </a:pPr>
             <a:r>
               <a:rPr sz="1000" b="1">
@@ -20944,7 +21003,7 @@
                   <a:srgbClr val="1E1E1E"/>
                 </a:solidFill>
               </a:rPr>
-              <a:t>26H2 is the cliff. 9 concurrent projects spike dev-load to 6.0. Without this hire, PLAT-01 or APP-SEP-01 will stall. This hire absorbs reservation/knowledge platform work, freeing senior devs for architecture.</a:t>
+              <a:t>Sep-Dec has 5 active projects needing ~3 developers. With 3 existing developers plus this hire ramping up, we cover it. This hire takes on reservation/knowledge platform work while senior developers focus on core AI infrastructure.</a:t>
             </a:r>
           </a:p>
           <a:p>
@@ -20952,11 +21011,6 @@
               <a:spcAft>
                 <a:spcPts val="400"/>
               </a:spcAft>
-              <a:defRPr sz="1000">
-                <a:solidFill>
-                  <a:srgbClr val="1E1E1E"/>
-                </a:solidFill>
-              </a:defRPr>
             </a:pPr>
             <a:r>
               <a:rPr sz="1000" b="1">
@@ -20972,7 +21026,7 @@
                   <a:srgbClr val="1E1E1E"/>
                 </a:solidFill>
               </a:rPr>
-              <a:t>27H1 has 3 heavy projects + DEVAI-01 ramping up. Second hire absorbs governance/staff-builder support so existing devs stay focused on backend separation.</a:t>
+              <a:t>Jan-Jun 2027 has 5 active projects needing ~4 developers (including 3 large ones). Second hire absorbs governance/staff-builder support so existing developers stay focused on backend separation.</a:t>
             </a:r>
           </a:p>
           <a:p>
@@ -20980,11 +21034,6 @@
               <a:spcAft>
                 <a:spcPts val="400"/>
               </a:spcAft>
-              <a:defRPr sz="1000">
-                <a:solidFill>
-                  <a:srgbClr val="1E1E1E"/>
-                </a:solidFill>
-              </a:defRPr>
             </a:pPr>
             <a:r>
               <a:rPr sz="1000" b="1">
@@ -21000,17 +21049,38 @@
                   <a:srgbClr val="1E1E1E"/>
                 </a:solidFill>
               </a:rPr>
-              <a:t>28H2 adds TENANT-01 and BOHRCORP-01 on top of ongoing PLAT-01 + APP-SEP-01. Dev-load hits 5.0. Third hire takes on SaaS foundation.</a:t>
+              <a:t>Jul-Dec 2028 adds SaaS foundation and Corporate Bohr SaaS on top of ongoing separation work — 6 projects needing ~5 developers. Third hire takes on SaaS foundation.</a:t>
             </a:r>
           </a:p>
           <a:p>
             <a:pPr>
-              <a:spcBef>
+              <a:spcAft>
                 <a:spcPts val="400"/>
-              </a:spcBef>
-            </a:pPr>
-          </a:p>
-          <a:p>
+              </a:spcAft>
+            </a:pPr>
+            <a:r>
+              <a:rPr sz="1000" b="1">
+                <a:solidFill>
+                  <a:srgbClr val="1A237E"/>
+                </a:solidFill>
+              </a:rPr>
+              <a:t>Schedule adjustment: </a:t>
+            </a:r>
+            <a:r>
+              <a:rPr sz="1000">
+                <a:solidFill>
+                  <a:srgbClr val="1E1E1E"/>
+                </a:solidFill>
+              </a:rPr>
+              <a:t>4 project starts (PLAT-01, APP-SEP-01, GOV-01, IAGPT-04) moved from Dec 2026 to Jan 2027 to match hiring pace. Impact is minimal — 1-month slip on multi-year projects.</a:t>
+            </a:r>
+          </a:p>
+          <a:p>
+            <a:pPr>
+              <a:spcAft>
+                <a:spcPts val="400"/>
+              </a:spcAft>
+            </a:pPr>
             <a:r>
               <a:rPr sz="1000" b="1">
                 <a:solidFill>
@@ -21025,7 +21095,7 @@
                   <a:srgbClr val="1E1E1E"/>
                 </a:solidFill>
               </a:rPr>
-              <a:t>Solid dev fundamentals (read code, debug, tests) · Git/PR literacy · Communication skills · Full-stack (Django/Go + Vue) · 2-4 years experience · Independent after 2-month ramp</a:t>
+              <a:t>Solid dev fundamentals · Git/PR familiarity · Communication skills · Full-stack (Django/Go + Vue) · 2-4 years experience · Independent after 2-month training</a:t>
             </a:r>
           </a:p>
           <a:p>
@@ -21043,24 +21113,1476 @@
                   <a:srgbClr val="1E1E1E"/>
                 </a:solidFill>
               </a:rPr>
-              <a:t>AI/ML expertise (building in-house) · Kubernetes/microservices (ARCH-01 defines) · SaaS platform experience (TENANT-01 is greenfield) · Senior architect-level (manager sets architecture)</a:t>
-            </a:r>
-          </a:p>
+              <a:t>AI/ML expertise · Kubernetes/microservices · SaaS platform experience · Senior architect-level · Education industry knowledge</a:t>
+            </a:r>
+          </a:p>
+        </p:txBody>
+      </p:sp>
+    </p:spTree>
+  </p:cSld>
+  <p:clrMapOvr>
+    <a:masterClrMapping/>
+  </p:clrMapOvr>
+</p:sld>
+</file>
+
+<file path=ppt/slides/slide7.xml><?xml version="1.0" encoding="utf-8"?>
+<p:sld xmlns:a="http://schemas.openxmlformats.org/drawingml/2006/main" xmlns:p="http://schemas.openxmlformats.org/presentationml/2006/main" xmlns:r="http://schemas.openxmlformats.org/officeDocument/2006/relationships">
+  <p:cSld>
+    <p:spTree>
+      <p:nvGrpSpPr>
+        <p:cNvPr id="1" name=""/>
+        <p:cNvGrpSpPr/>
+        <p:nvPr/>
+      </p:nvGrpSpPr>
+      <p:grpSpPr/>
+      <p:sp>
+        <p:nvSpPr>
+          <p:cNvPr id="2" name="Rectangle 1"/>
+          <p:cNvSpPr/>
+          <p:nvPr/>
+        </p:nvSpPr>
+        <p:spPr>
+          <a:xfrm>
+            <a:off x="0" y="0"/>
+            <a:ext cx="12191695" cy="6858000"/>
+          </a:xfrm>
+          <a:prstGeom prst="rect">
+            <a:avLst/>
+          </a:prstGeom>
+          <a:solidFill>
+            <a:srgbClr val="FFFFFF"/>
+          </a:solidFill>
+          <a:ln>
+            <a:noFill/>
+          </a:ln>
+        </p:spPr>
+        <p:style>
+          <a:lnRef idx="1">
+            <a:schemeClr val="accent1"/>
+          </a:lnRef>
+          <a:fillRef idx="3">
+            <a:schemeClr val="accent1"/>
+          </a:fillRef>
+          <a:effectRef idx="2">
+            <a:schemeClr val="accent1"/>
+          </a:effectRef>
+          <a:fontRef idx="minor">
+            <a:schemeClr val="lt1"/>
+          </a:fontRef>
+        </p:style>
+        <p:txBody>
+          <a:bodyPr rtlCol="0" anchor="ctr"/>
+          <a:lstStyle/>
+          <a:p>
+            <a:pPr algn="ctr"/>
+          </a:p>
+        </p:txBody>
+      </p:sp>
+      <p:sp>
+        <p:nvSpPr>
+          <p:cNvPr id="3" name="TextBox 2"/>
+          <p:cNvSpPr txBox="1"/>
+          <p:nvPr/>
+        </p:nvSpPr>
+        <p:spPr>
+          <a:xfrm>
+            <a:off x="457200" y="182880"/>
+            <a:ext cx="10972800" cy="457200"/>
+          </a:xfrm>
+          <a:prstGeom prst="rect">
+            <a:avLst/>
+          </a:prstGeom>
+          <a:noFill/>
+        </p:spPr>
+        <p:txBody>
+          <a:bodyPr wrap="none">
+            <a:spAutoFit/>
+          </a:bodyPr>
+          <a:lstStyle/>
           <a:p>
             <a:pPr>
-              <a:spcBef>
+              <a:defRPr sz="2400" b="1">
+                <a:solidFill>
+                  <a:srgbClr val="1A237E"/>
+                </a:solidFill>
+              </a:defRPr>
+            </a:pPr>
+            <a:r>
+              <a:t>5 — HIRING PLAN: When and Who</a:t>
+            </a:r>
+          </a:p>
+        </p:txBody>
+      </p:sp>
+      <p:sp>
+        <p:nvSpPr>
+          <p:cNvPr id="4" name="TextBox 3"/>
+          <p:cNvSpPr txBox="1"/>
+          <p:nvPr/>
+        </p:nvSpPr>
+        <p:spPr>
+          <a:xfrm>
+            <a:off x="457200" y="685800"/>
+            <a:ext cx="11247120" cy="320040"/>
+          </a:xfrm>
+          <a:prstGeom prst="rect">
+            <a:avLst/>
+          </a:prstGeom>
+          <a:noFill/>
+        </p:spPr>
+        <p:txBody>
+          <a:bodyPr wrap="none">
+            <a:spAutoFit/>
+          </a:bodyPr>
+          <a:lstStyle/>
+          <a:p>
+            <a:pPr>
+              <a:defRPr sz="1100">
+                <a:solidFill>
+                  <a:srgbClr val="616161"/>
+                </a:solidFill>
+              </a:defRPr>
+            </a:pPr>
+            <a:r>
+              <a:t>Current: 3 developers + 1 manager (training/management). Target: 6 developers. 4 project starts pushed from Dec 2026 → Jan 2027 to match hiring pace.</a:t>
+            </a:r>
+          </a:p>
+        </p:txBody>
+      </p:sp>
+      <p:sp>
+        <p:nvSpPr>
+          <p:cNvPr id="5" name="TextBox 4"/>
+          <p:cNvSpPr txBox="1"/>
+          <p:nvPr/>
+        </p:nvSpPr>
+        <p:spPr>
+          <a:xfrm>
+            <a:off x="2103120" y="1097280"/>
+            <a:ext cx="1097280" cy="320040"/>
+          </a:xfrm>
+          <a:prstGeom prst="rect">
+            <a:avLst/>
+          </a:prstGeom>
+          <a:noFill/>
+        </p:spPr>
+        <p:txBody>
+          <a:bodyPr wrap="none">
+            <a:spAutoFit/>
+          </a:bodyPr>
+          <a:lstStyle/>
+          <a:p>
+            <a:pPr algn="ctr">
+              <a:defRPr sz="900" b="1">
+                <a:solidFill>
+                  <a:srgbClr val="1A237E"/>
+                </a:solidFill>
+              </a:defRPr>
+            </a:pPr>
+            <a:r>
+              <a:t>'26 H1</a:t>
+            </a:r>
+          </a:p>
+        </p:txBody>
+      </p:sp>
+      <p:sp>
+        <p:nvSpPr>
+          <p:cNvPr id="6" name="TextBox 5"/>
+          <p:cNvSpPr txBox="1"/>
+          <p:nvPr/>
+        </p:nvSpPr>
+        <p:spPr>
+          <a:xfrm>
+            <a:off x="3200400" y="1097280"/>
+            <a:ext cx="1097280" cy="320040"/>
+          </a:xfrm>
+          <a:prstGeom prst="rect">
+            <a:avLst/>
+          </a:prstGeom>
+          <a:noFill/>
+        </p:spPr>
+        <p:txBody>
+          <a:bodyPr wrap="none">
+            <a:spAutoFit/>
+          </a:bodyPr>
+          <a:lstStyle/>
+          <a:p>
+            <a:pPr algn="ctr">
+              <a:defRPr sz="900" b="1">
+                <a:solidFill>
+                  <a:srgbClr val="1A237E"/>
+                </a:solidFill>
+              </a:defRPr>
+            </a:pPr>
+            <a:r>
+              <a:t>'26 H2</a:t>
+            </a:r>
+          </a:p>
+        </p:txBody>
+      </p:sp>
+      <p:sp>
+        <p:nvSpPr>
+          <p:cNvPr id="7" name="TextBox 6"/>
+          <p:cNvSpPr txBox="1"/>
+          <p:nvPr/>
+        </p:nvSpPr>
+        <p:spPr>
+          <a:xfrm>
+            <a:off x="4297680" y="1097280"/>
+            <a:ext cx="1097280" cy="320040"/>
+          </a:xfrm>
+          <a:prstGeom prst="rect">
+            <a:avLst/>
+          </a:prstGeom>
+          <a:noFill/>
+        </p:spPr>
+        <p:txBody>
+          <a:bodyPr wrap="none">
+            <a:spAutoFit/>
+          </a:bodyPr>
+          <a:lstStyle/>
+          <a:p>
+            <a:pPr algn="ctr">
+              <a:defRPr sz="900" b="1">
+                <a:solidFill>
+                  <a:srgbClr val="1A237E"/>
+                </a:solidFill>
+              </a:defRPr>
+            </a:pPr>
+            <a:r>
+              <a:t>'27 H1</a:t>
+            </a:r>
+          </a:p>
+        </p:txBody>
+      </p:sp>
+      <p:sp>
+        <p:nvSpPr>
+          <p:cNvPr id="8" name="TextBox 7"/>
+          <p:cNvSpPr txBox="1"/>
+          <p:nvPr/>
+        </p:nvSpPr>
+        <p:spPr>
+          <a:xfrm>
+            <a:off x="5394960" y="1097280"/>
+            <a:ext cx="1097280" cy="320040"/>
+          </a:xfrm>
+          <a:prstGeom prst="rect">
+            <a:avLst/>
+          </a:prstGeom>
+          <a:noFill/>
+        </p:spPr>
+        <p:txBody>
+          <a:bodyPr wrap="none">
+            <a:spAutoFit/>
+          </a:bodyPr>
+          <a:lstStyle/>
+          <a:p>
+            <a:pPr algn="ctr">
+              <a:defRPr sz="900" b="1">
+                <a:solidFill>
+                  <a:srgbClr val="1A237E"/>
+                </a:solidFill>
+              </a:defRPr>
+            </a:pPr>
+            <a:r>
+              <a:t>'27 H2</a:t>
+            </a:r>
+          </a:p>
+        </p:txBody>
+      </p:sp>
+      <p:sp>
+        <p:nvSpPr>
+          <p:cNvPr id="9" name="TextBox 8"/>
+          <p:cNvSpPr txBox="1"/>
+          <p:nvPr/>
+        </p:nvSpPr>
+        <p:spPr>
+          <a:xfrm>
+            <a:off x="6492240" y="1097280"/>
+            <a:ext cx="1097280" cy="320040"/>
+          </a:xfrm>
+          <a:prstGeom prst="rect">
+            <a:avLst/>
+          </a:prstGeom>
+          <a:noFill/>
+        </p:spPr>
+        <p:txBody>
+          <a:bodyPr wrap="none">
+            <a:spAutoFit/>
+          </a:bodyPr>
+          <a:lstStyle/>
+          <a:p>
+            <a:pPr algn="ctr">
+              <a:defRPr sz="900" b="1">
+                <a:solidFill>
+                  <a:srgbClr val="1A237E"/>
+                </a:solidFill>
+              </a:defRPr>
+            </a:pPr>
+            <a:r>
+              <a:t>'28 H1</a:t>
+            </a:r>
+          </a:p>
+        </p:txBody>
+      </p:sp>
+      <p:sp>
+        <p:nvSpPr>
+          <p:cNvPr id="10" name="TextBox 9"/>
+          <p:cNvSpPr txBox="1"/>
+          <p:nvPr/>
+        </p:nvSpPr>
+        <p:spPr>
+          <a:xfrm>
+            <a:off x="7589520" y="1097280"/>
+            <a:ext cx="1097280" cy="320040"/>
+          </a:xfrm>
+          <a:prstGeom prst="rect">
+            <a:avLst/>
+          </a:prstGeom>
+          <a:noFill/>
+        </p:spPr>
+        <p:txBody>
+          <a:bodyPr wrap="none">
+            <a:spAutoFit/>
+          </a:bodyPr>
+          <a:lstStyle/>
+          <a:p>
+            <a:pPr algn="ctr">
+              <a:defRPr sz="900" b="1">
+                <a:solidFill>
+                  <a:srgbClr val="1A237E"/>
+                </a:solidFill>
+              </a:defRPr>
+            </a:pPr>
+            <a:r>
+              <a:t>'28 H2</a:t>
+            </a:r>
+          </a:p>
+        </p:txBody>
+      </p:sp>
+      <p:sp>
+        <p:nvSpPr>
+          <p:cNvPr id="11" name="TextBox 10"/>
+          <p:cNvSpPr txBox="1"/>
+          <p:nvPr/>
+        </p:nvSpPr>
+        <p:spPr>
+          <a:xfrm>
+            <a:off x="8686800" y="1097280"/>
+            <a:ext cx="1097280" cy="320040"/>
+          </a:xfrm>
+          <a:prstGeom prst="rect">
+            <a:avLst/>
+          </a:prstGeom>
+          <a:noFill/>
+        </p:spPr>
+        <p:txBody>
+          <a:bodyPr wrap="none">
+            <a:spAutoFit/>
+          </a:bodyPr>
+          <a:lstStyle/>
+          <a:p>
+            <a:pPr algn="ctr">
+              <a:defRPr sz="900" b="1">
+                <a:solidFill>
+                  <a:srgbClr val="1A237E"/>
+                </a:solidFill>
+              </a:defRPr>
+            </a:pPr>
+            <a:r>
+              <a:t>'29 H1</a:t>
+            </a:r>
+          </a:p>
+        </p:txBody>
+      </p:sp>
+      <p:sp>
+        <p:nvSpPr>
+          <p:cNvPr id="12" name="TextBox 11"/>
+          <p:cNvSpPr txBox="1"/>
+          <p:nvPr/>
+        </p:nvSpPr>
+        <p:spPr>
+          <a:xfrm>
+            <a:off x="9784080" y="1097280"/>
+            <a:ext cx="1097280" cy="320040"/>
+          </a:xfrm>
+          <a:prstGeom prst="rect">
+            <a:avLst/>
+          </a:prstGeom>
+          <a:noFill/>
+        </p:spPr>
+        <p:txBody>
+          <a:bodyPr wrap="none">
+            <a:spAutoFit/>
+          </a:bodyPr>
+          <a:lstStyle/>
+          <a:p>
+            <a:pPr algn="ctr">
+              <a:defRPr sz="900" b="1">
+                <a:solidFill>
+                  <a:srgbClr val="1A237E"/>
+                </a:solidFill>
+              </a:defRPr>
+            </a:pPr>
+            <a:r>
+              <a:t>'29 H2</a:t>
+            </a:r>
+          </a:p>
+        </p:txBody>
+      </p:sp>
+      <p:sp>
+        <p:nvSpPr>
+          <p:cNvPr id="13" name="TextBox 12"/>
+          <p:cNvSpPr txBox="1"/>
+          <p:nvPr/>
+        </p:nvSpPr>
+        <p:spPr>
+          <a:xfrm>
+            <a:off x="10881360" y="1097280"/>
+            <a:ext cx="1097280" cy="320040"/>
+          </a:xfrm>
+          <a:prstGeom prst="rect">
+            <a:avLst/>
+          </a:prstGeom>
+          <a:noFill/>
+        </p:spPr>
+        <p:txBody>
+          <a:bodyPr wrap="none">
+            <a:spAutoFit/>
+          </a:bodyPr>
+          <a:lstStyle/>
+          <a:p>
+            <a:pPr algn="ctr">
+              <a:defRPr sz="900" b="1">
+                <a:solidFill>
+                  <a:srgbClr val="1A237E"/>
+                </a:solidFill>
+              </a:defRPr>
+            </a:pPr>
+            <a:r>
+              <a:t>2029+</a:t>
+            </a:r>
+          </a:p>
+        </p:txBody>
+      </p:sp>
+      <p:sp>
+        <p:nvSpPr>
+          <p:cNvPr id="14" name="TextBox 13"/>
+          <p:cNvSpPr txBox="1"/>
+          <p:nvPr/>
+        </p:nvSpPr>
+        <p:spPr>
+          <a:xfrm>
+            <a:off x="457200" y="1554480"/>
+            <a:ext cx="1645920" cy="274320"/>
+          </a:xfrm>
+          <a:prstGeom prst="rect">
+            <a:avLst/>
+          </a:prstGeom>
+          <a:noFill/>
+        </p:spPr>
+        <p:txBody>
+          <a:bodyPr wrap="none">
+            <a:spAutoFit/>
+          </a:bodyPr>
+          <a:lstStyle/>
+          <a:p>
+            <a:pPr>
+              <a:defRPr sz="1100" b="1">
+                <a:solidFill>
+                  <a:srgbClr val="1E1E1E"/>
+                </a:solidFill>
+              </a:defRPr>
+            </a:pPr>
+            <a:r>
+              <a:t>📅 New hires</a:t>
+            </a:r>
+          </a:p>
+        </p:txBody>
+      </p:sp>
+      <p:sp>
+        <p:nvSpPr>
+          <p:cNvPr id="15" name="Rounded Rectangle 14"/>
+          <p:cNvSpPr/>
+          <p:nvPr/>
+        </p:nvSpPr>
+        <p:spPr>
+          <a:xfrm>
+            <a:off x="3218688" y="1554480"/>
+            <a:ext cx="1060704" cy="548640"/>
+          </a:xfrm>
+          <a:prstGeom prst="roundRect">
+            <a:avLst/>
+          </a:prstGeom>
+          <a:solidFill>
+            <a:srgbClr val="1565C0"/>
+          </a:solidFill>
+          <a:ln>
+            <a:noFill/>
+          </a:ln>
+        </p:spPr>
+        <p:style>
+          <a:lnRef idx="1">
+            <a:schemeClr val="accent1"/>
+          </a:lnRef>
+          <a:fillRef idx="3">
+            <a:schemeClr val="accent1"/>
+          </a:fillRef>
+          <a:effectRef idx="2">
+            <a:schemeClr val="accent1"/>
+          </a:effectRef>
+          <a:fontRef idx="minor">
+            <a:schemeClr val="lt1"/>
+          </a:fontRef>
+        </p:style>
+        <p:txBody>
+          <a:bodyPr rtlCol="0" anchor="ctr" wrap="square" tIns="18288"/>
+          <a:lstStyle/>
+          <a:p>
+            <a:pPr algn="ctr">
+              <a:defRPr sz="800">
+                <a:solidFill>
+                  <a:srgbClr val="FFFFFF"/>
+                </a:solidFill>
+              </a:defRPr>
+            </a:pPr>
+            <a:r>
+              <a:t>Sep 2026</a:t>
+            </a:r>
+          </a:p>
+          <a:p>
+            <a:pPr algn="ctr">
+              <a:defRPr sz="1000" b="1">
+                <a:solidFill>
+                  <a:srgbClr val="FFFFFF"/>
+                </a:solidFill>
+              </a:defRPr>
+            </a:pPr>
+            <a:r>
+              <a:t>Hire #1</a:t>
+            </a:r>
+          </a:p>
+        </p:txBody>
+      </p:sp>
+      <p:sp>
+        <p:nvSpPr>
+          <p:cNvPr id="16" name="Rounded Rectangle 15"/>
+          <p:cNvSpPr/>
+          <p:nvPr/>
+        </p:nvSpPr>
+        <p:spPr>
+          <a:xfrm>
+            <a:off x="4315968" y="1554480"/>
+            <a:ext cx="1060704" cy="548640"/>
+          </a:xfrm>
+          <a:prstGeom prst="roundRect">
+            <a:avLst/>
+          </a:prstGeom>
+          <a:solidFill>
+            <a:srgbClr val="00838F"/>
+          </a:solidFill>
+          <a:ln>
+            <a:noFill/>
+          </a:ln>
+        </p:spPr>
+        <p:style>
+          <a:lnRef idx="1">
+            <a:schemeClr val="accent1"/>
+          </a:lnRef>
+          <a:fillRef idx="3">
+            <a:schemeClr val="accent1"/>
+          </a:fillRef>
+          <a:effectRef idx="2">
+            <a:schemeClr val="accent1"/>
+          </a:effectRef>
+          <a:fontRef idx="minor">
+            <a:schemeClr val="lt1"/>
+          </a:fontRef>
+        </p:style>
+        <p:txBody>
+          <a:bodyPr rtlCol="0" anchor="ctr" wrap="square" tIns="18288"/>
+          <a:lstStyle/>
+          <a:p>
+            <a:pPr algn="ctr">
+              <a:defRPr sz="800">
+                <a:solidFill>
+                  <a:srgbClr val="FFFFFF"/>
+                </a:solidFill>
+              </a:defRPr>
+            </a:pPr>
+            <a:r>
+              <a:t>Apr 2027</a:t>
+            </a:r>
+          </a:p>
+          <a:p>
+            <a:pPr algn="ctr">
+              <a:defRPr sz="1000" b="1">
+                <a:solidFill>
+                  <a:srgbClr val="FFFFFF"/>
+                </a:solidFill>
+              </a:defRPr>
+            </a:pPr>
+            <a:r>
+              <a:t>Hire #2</a:t>
+            </a:r>
+          </a:p>
+        </p:txBody>
+      </p:sp>
+      <p:sp>
+        <p:nvSpPr>
+          <p:cNvPr id="17" name="Rounded Rectangle 16"/>
+          <p:cNvSpPr/>
+          <p:nvPr/>
+        </p:nvSpPr>
+        <p:spPr>
+          <a:xfrm>
+            <a:off x="6510528" y="1554480"/>
+            <a:ext cx="1060704" cy="548640"/>
+          </a:xfrm>
+          <a:prstGeom prst="roundRect">
+            <a:avLst/>
+          </a:prstGeom>
+          <a:solidFill>
+            <a:srgbClr val="6A1B9A"/>
+          </a:solidFill>
+          <a:ln>
+            <a:noFill/>
+          </a:ln>
+        </p:spPr>
+        <p:style>
+          <a:lnRef idx="1">
+            <a:schemeClr val="accent1"/>
+          </a:lnRef>
+          <a:fillRef idx="3">
+            <a:schemeClr val="accent1"/>
+          </a:fillRef>
+          <a:effectRef idx="2">
+            <a:schemeClr val="accent1"/>
+          </a:effectRef>
+          <a:fontRef idx="minor">
+            <a:schemeClr val="lt1"/>
+          </a:fontRef>
+        </p:style>
+        <p:txBody>
+          <a:bodyPr rtlCol="0" anchor="ctr" wrap="square" tIns="18288"/>
+          <a:lstStyle/>
+          <a:p>
+            <a:pPr algn="ctr">
+              <a:defRPr sz="800">
+                <a:solidFill>
+                  <a:srgbClr val="FFFFFF"/>
+                </a:solidFill>
+              </a:defRPr>
+            </a:pPr>
+            <a:r>
+              <a:t>Jan 2028</a:t>
+            </a:r>
+          </a:p>
+          <a:p>
+            <a:pPr algn="ctr">
+              <a:defRPr sz="1000" b="1">
+                <a:solidFill>
+                  <a:srgbClr val="FFFFFF"/>
+                </a:solidFill>
+              </a:defRPr>
+            </a:pPr>
+            <a:r>
+              <a:t>Hire #3</a:t>
+            </a:r>
+          </a:p>
+        </p:txBody>
+      </p:sp>
+      <p:sp>
+        <p:nvSpPr>
+          <p:cNvPr id="18" name="TextBox 17"/>
+          <p:cNvSpPr txBox="1"/>
+          <p:nvPr/>
+        </p:nvSpPr>
+        <p:spPr>
+          <a:xfrm>
+            <a:off x="457200" y="2286000"/>
+            <a:ext cx="1645920" cy="274320"/>
+          </a:xfrm>
+          <a:prstGeom prst="rect">
+            <a:avLst/>
+          </a:prstGeom>
+          <a:noFill/>
+        </p:spPr>
+        <p:txBody>
+          <a:bodyPr wrap="none">
+            <a:spAutoFit/>
+          </a:bodyPr>
+          <a:lstStyle/>
+          <a:p>
+            <a:pPr>
+              <a:defRPr sz="1100" b="1">
+                <a:solidFill>
+                  <a:srgbClr val="1E1E1E"/>
+                </a:solidFill>
+              </a:defRPr>
+            </a:pPr>
+            <a:r>
+              <a:t>👥 Team size</a:t>
+            </a:r>
+          </a:p>
+        </p:txBody>
+      </p:sp>
+      <p:sp>
+        <p:nvSpPr>
+          <p:cNvPr id="19" name="Rounded Rectangle 18"/>
+          <p:cNvSpPr/>
+          <p:nvPr/>
+        </p:nvSpPr>
+        <p:spPr>
+          <a:xfrm>
+            <a:off x="2121408" y="2286000"/>
+            <a:ext cx="2157984" cy="365760"/>
+          </a:xfrm>
+          <a:prstGeom prst="roundRect">
+            <a:avLst/>
+          </a:prstGeom>
+          <a:solidFill>
+            <a:srgbClr val="2E7D32"/>
+          </a:solidFill>
+          <a:ln>
+            <a:noFill/>
+          </a:ln>
+        </p:spPr>
+        <p:style>
+          <a:lnRef idx="1">
+            <a:schemeClr val="accent1"/>
+          </a:lnRef>
+          <a:fillRef idx="3">
+            <a:schemeClr val="accent1"/>
+          </a:fillRef>
+          <a:effectRef idx="2">
+            <a:schemeClr val="accent1"/>
+          </a:effectRef>
+          <a:fontRef idx="minor">
+            <a:schemeClr val="lt1"/>
+          </a:fontRef>
+        </p:style>
+        <p:txBody>
+          <a:bodyPr rtlCol="0" anchor="ctr" lIns="36576"/>
+          <a:lstStyle/>
+          <a:p>
+            <a:pPr algn="ctr">
+              <a:defRPr sz="900" b="1">
+                <a:solidFill>
+                  <a:srgbClr val="FFFFFF"/>
+                </a:solidFill>
+              </a:defRPr>
+            </a:pPr>
+            <a:r>
+              <a:t>3 developers</a:t>
+            </a:r>
+          </a:p>
+        </p:txBody>
+      </p:sp>
+      <p:sp>
+        <p:nvSpPr>
+          <p:cNvPr id="20" name="Rounded Rectangle 19"/>
+          <p:cNvSpPr/>
+          <p:nvPr/>
+        </p:nvSpPr>
+        <p:spPr>
+          <a:xfrm>
+            <a:off x="4315968" y="2286000"/>
+            <a:ext cx="2157984" cy="365760"/>
+          </a:xfrm>
+          <a:prstGeom prst="roundRect">
+            <a:avLst/>
+          </a:prstGeom>
+          <a:solidFill>
+            <a:srgbClr val="2E7D32"/>
+          </a:solidFill>
+          <a:ln>
+            <a:noFill/>
+          </a:ln>
+        </p:spPr>
+        <p:style>
+          <a:lnRef idx="1">
+            <a:schemeClr val="accent1"/>
+          </a:lnRef>
+          <a:fillRef idx="3">
+            <a:schemeClr val="accent1"/>
+          </a:fillRef>
+          <a:effectRef idx="2">
+            <a:schemeClr val="accent1"/>
+          </a:effectRef>
+          <a:fontRef idx="minor">
+            <a:schemeClr val="lt1"/>
+          </a:fontRef>
+        </p:style>
+        <p:txBody>
+          <a:bodyPr rtlCol="0" anchor="ctr" lIns="36576"/>
+          <a:lstStyle/>
+          <a:p>
+            <a:pPr algn="ctr">
+              <a:defRPr sz="900" b="1">
+                <a:solidFill>
+                  <a:srgbClr val="FFFFFF"/>
+                </a:solidFill>
+              </a:defRPr>
+            </a:pPr>
+            <a:r>
+              <a:t>4 developers</a:t>
+            </a:r>
+          </a:p>
+        </p:txBody>
+      </p:sp>
+      <p:sp>
+        <p:nvSpPr>
+          <p:cNvPr id="21" name="Rounded Rectangle 20"/>
+          <p:cNvSpPr/>
+          <p:nvPr/>
+        </p:nvSpPr>
+        <p:spPr>
+          <a:xfrm>
+            <a:off x="6510528" y="2286000"/>
+            <a:ext cx="2157984" cy="365760"/>
+          </a:xfrm>
+          <a:prstGeom prst="roundRect">
+            <a:avLst/>
+          </a:prstGeom>
+          <a:solidFill>
+            <a:srgbClr val="1565C0"/>
+          </a:solidFill>
+          <a:ln>
+            <a:noFill/>
+          </a:ln>
+        </p:spPr>
+        <p:style>
+          <a:lnRef idx="1">
+            <a:schemeClr val="accent1"/>
+          </a:lnRef>
+          <a:fillRef idx="3">
+            <a:schemeClr val="accent1"/>
+          </a:fillRef>
+          <a:effectRef idx="2">
+            <a:schemeClr val="accent1"/>
+          </a:effectRef>
+          <a:fontRef idx="minor">
+            <a:schemeClr val="lt1"/>
+          </a:fontRef>
+        </p:style>
+        <p:txBody>
+          <a:bodyPr rtlCol="0" anchor="ctr" lIns="36576"/>
+          <a:lstStyle/>
+          <a:p>
+            <a:pPr algn="ctr">
+              <a:defRPr sz="900" b="1">
+                <a:solidFill>
+                  <a:srgbClr val="FFFFFF"/>
+                </a:solidFill>
+              </a:defRPr>
+            </a:pPr>
+            <a:r>
+              <a:t>5 developers</a:t>
+            </a:r>
+          </a:p>
+        </p:txBody>
+      </p:sp>
+      <p:sp>
+        <p:nvSpPr>
+          <p:cNvPr id="22" name="Rounded Rectangle 21"/>
+          <p:cNvSpPr/>
+          <p:nvPr/>
+        </p:nvSpPr>
+        <p:spPr>
+          <a:xfrm>
+            <a:off x="8705088" y="2286000"/>
+            <a:ext cx="3255264" cy="365760"/>
+          </a:xfrm>
+          <a:prstGeom prst="roundRect">
+            <a:avLst/>
+          </a:prstGeom>
+          <a:solidFill>
+            <a:srgbClr val="1565C0"/>
+          </a:solidFill>
+          <a:ln>
+            <a:noFill/>
+          </a:ln>
+        </p:spPr>
+        <p:style>
+          <a:lnRef idx="1">
+            <a:schemeClr val="accent1"/>
+          </a:lnRef>
+          <a:fillRef idx="3">
+            <a:schemeClr val="accent1"/>
+          </a:fillRef>
+          <a:effectRef idx="2">
+            <a:schemeClr val="accent1"/>
+          </a:effectRef>
+          <a:fontRef idx="minor">
+            <a:schemeClr val="lt1"/>
+          </a:fontRef>
+        </p:style>
+        <p:txBody>
+          <a:bodyPr rtlCol="0" anchor="ctr" lIns="36576"/>
+          <a:lstStyle/>
+          <a:p>
+            <a:pPr algn="ctr">
+              <a:defRPr sz="900" b="1">
+                <a:solidFill>
+                  <a:srgbClr val="FFFFFF"/>
+                </a:solidFill>
+              </a:defRPr>
+            </a:pPr>
+            <a:r>
+              <a:t>6 developers</a:t>
+            </a:r>
+          </a:p>
+        </p:txBody>
+      </p:sp>
+      <p:sp>
+        <p:nvSpPr>
+          <p:cNvPr id="23" name="TextBox 22"/>
+          <p:cNvSpPr txBox="1"/>
+          <p:nvPr/>
+        </p:nvSpPr>
+        <p:spPr>
+          <a:xfrm>
+            <a:off x="457200" y="2834640"/>
+            <a:ext cx="1645920" cy="274320"/>
+          </a:xfrm>
+          <a:prstGeom prst="rect">
+            <a:avLst/>
+          </a:prstGeom>
+          <a:noFill/>
+        </p:spPr>
+        <p:txBody>
+          <a:bodyPr wrap="none">
+            <a:spAutoFit/>
+          </a:bodyPr>
+          <a:lstStyle/>
+          <a:p>
+            <a:pPr>
+              <a:defRPr sz="1100" b="1">
+                <a:solidFill>
+                  <a:srgbClr val="1E1E1E"/>
+                </a:solidFill>
+              </a:defRPr>
+            </a:pPr>
+            <a:r>
+              <a:t>📊 Workload vs team</a:t>
+            </a:r>
+          </a:p>
+        </p:txBody>
+      </p:sp>
+      <p:sp>
+        <p:nvSpPr>
+          <p:cNvPr id="24" name="Rounded Rectangle 23"/>
+          <p:cNvSpPr/>
+          <p:nvPr/>
+        </p:nvSpPr>
+        <p:spPr>
+          <a:xfrm>
+            <a:off x="2121408" y="2834640"/>
+            <a:ext cx="2157984" cy="502920"/>
+          </a:xfrm>
+          <a:prstGeom prst="roundRect">
+            <a:avLst/>
+          </a:prstGeom>
+          <a:solidFill>
+            <a:srgbClr val="2E7D32"/>
+          </a:solidFill>
+          <a:ln>
+            <a:noFill/>
+          </a:ln>
+        </p:spPr>
+        <p:style>
+          <a:lnRef idx="1">
+            <a:schemeClr val="accent1"/>
+          </a:lnRef>
+          <a:fillRef idx="3">
+            <a:schemeClr val="accent1"/>
+          </a:fillRef>
+          <a:effectRef idx="2">
+            <a:schemeClr val="accent1"/>
+          </a:effectRef>
+          <a:fontRef idx="minor">
+            <a:schemeClr val="lt1"/>
+          </a:fontRef>
+        </p:style>
+        <p:txBody>
+          <a:bodyPr rtlCol="0" anchor="ctr" wrap="square" tIns="18288"/>
+          <a:lstStyle/>
+          <a:p>
+            <a:pPr algn="ctr">
+              <a:defRPr sz="700" b="1">
+                <a:solidFill>
+                  <a:srgbClr val="FFFFFF"/>
+                </a:solidFill>
+              </a:defRPr>
+            </a:pPr>
+            <a:r>
+              <a:t>Need ~2, have 3</a:t>
+            </a:r>
+          </a:p>
+          <a:p>
+            <a:pPr algn="ctr">
+              <a:defRPr sz="700" b="0">
+                <a:solidFill>
+                  <a:srgbClr val="FFFFFF"/>
+                </a:solidFill>
+              </a:defRPr>
+            </a:pPr>
+            <a:r>
+              <a:t>✅ OK</a:t>
+            </a:r>
+          </a:p>
+        </p:txBody>
+      </p:sp>
+      <p:sp>
+        <p:nvSpPr>
+          <p:cNvPr id="25" name="Rounded Rectangle 24"/>
+          <p:cNvSpPr/>
+          <p:nvPr/>
+        </p:nvSpPr>
+        <p:spPr>
+          <a:xfrm>
+            <a:off x="3218688" y="2834640"/>
+            <a:ext cx="1060704" cy="502920"/>
+          </a:xfrm>
+          <a:prstGeom prst="roundRect">
+            <a:avLst/>
+          </a:prstGeom>
+          <a:solidFill>
+            <a:srgbClr val="2E7D32"/>
+          </a:solidFill>
+          <a:ln>
+            <a:noFill/>
+          </a:ln>
+        </p:spPr>
+        <p:style>
+          <a:lnRef idx="1">
+            <a:schemeClr val="accent1"/>
+          </a:lnRef>
+          <a:fillRef idx="3">
+            <a:schemeClr val="accent1"/>
+          </a:fillRef>
+          <a:effectRef idx="2">
+            <a:schemeClr val="accent1"/>
+          </a:effectRef>
+          <a:fontRef idx="minor">
+            <a:schemeClr val="lt1"/>
+          </a:fontRef>
+        </p:style>
+        <p:txBody>
+          <a:bodyPr rtlCol="0" anchor="ctr" wrap="square" tIns="18288"/>
+          <a:lstStyle/>
+          <a:p>
+            <a:pPr algn="ctr">
+              <a:defRPr sz="700" b="1">
+                <a:solidFill>
+                  <a:srgbClr val="FFFFFF"/>
+                </a:solidFill>
+              </a:defRPr>
+            </a:pPr>
+            <a:r>
+              <a:t>Need ~3, have 3+1ᵃ</a:t>
+            </a:r>
+          </a:p>
+          <a:p>
+            <a:pPr algn="ctr">
+              <a:defRPr sz="700" b="0">
+                <a:solidFill>
+                  <a:srgbClr val="FFFFFF"/>
+                </a:solidFill>
+              </a:defRPr>
+            </a:pPr>
+            <a:r>
+              <a:t>✅ OK (ramping)</a:t>
+            </a:r>
+          </a:p>
+        </p:txBody>
+      </p:sp>
+      <p:sp>
+        <p:nvSpPr>
+          <p:cNvPr id="26" name="Rounded Rectangle 25"/>
+          <p:cNvSpPr/>
+          <p:nvPr/>
+        </p:nvSpPr>
+        <p:spPr>
+          <a:xfrm>
+            <a:off x="4315968" y="2834640"/>
+            <a:ext cx="2157984" cy="502920"/>
+          </a:xfrm>
+          <a:prstGeom prst="roundRect">
+            <a:avLst/>
+          </a:prstGeom>
+          <a:solidFill>
+            <a:srgbClr val="2E7D32"/>
+          </a:solidFill>
+          <a:ln>
+            <a:noFill/>
+          </a:ln>
+        </p:spPr>
+        <p:style>
+          <a:lnRef idx="1">
+            <a:schemeClr val="accent1"/>
+          </a:lnRef>
+          <a:fillRef idx="3">
+            <a:schemeClr val="accent1"/>
+          </a:fillRef>
+          <a:effectRef idx="2">
+            <a:schemeClr val="accent1"/>
+          </a:effectRef>
+          <a:fontRef idx="minor">
+            <a:schemeClr val="lt1"/>
+          </a:fontRef>
+        </p:style>
+        <p:txBody>
+          <a:bodyPr rtlCol="0" anchor="ctr" wrap="square" tIns="18288"/>
+          <a:lstStyle/>
+          <a:p>
+            <a:pPr algn="ctr">
+              <a:defRPr sz="700" b="1">
+                <a:solidFill>
+                  <a:srgbClr val="FFFFFF"/>
+                </a:solidFill>
+              </a:defRPr>
+            </a:pPr>
+            <a:r>
+              <a:t>Need ~4, have 4</a:t>
+            </a:r>
+          </a:p>
+          <a:p>
+            <a:pPr algn="ctr">
+              <a:defRPr sz="700" b="0">
+                <a:solidFill>
+                  <a:srgbClr val="FFFFFF"/>
+                </a:solidFill>
+              </a:defRPr>
+            </a:pPr>
+            <a:r>
+              <a:t>✅ Covered</a:t>
+            </a:r>
+          </a:p>
+        </p:txBody>
+      </p:sp>
+      <p:sp>
+        <p:nvSpPr>
+          <p:cNvPr id="27" name="Rounded Rectangle 26"/>
+          <p:cNvSpPr/>
+          <p:nvPr/>
+        </p:nvSpPr>
+        <p:spPr>
+          <a:xfrm>
+            <a:off x="5413248" y="2834640"/>
+            <a:ext cx="1060704" cy="502920"/>
+          </a:xfrm>
+          <a:prstGeom prst="roundRect">
+            <a:avLst/>
+          </a:prstGeom>
+          <a:solidFill>
+            <a:srgbClr val="2E7D32"/>
+          </a:solidFill>
+          <a:ln>
+            <a:noFill/>
+          </a:ln>
+        </p:spPr>
+        <p:style>
+          <a:lnRef idx="1">
+            <a:schemeClr val="accent1"/>
+          </a:lnRef>
+          <a:fillRef idx="3">
+            <a:schemeClr val="accent1"/>
+          </a:fillRef>
+          <a:effectRef idx="2">
+            <a:schemeClr val="accent1"/>
+          </a:effectRef>
+          <a:fontRef idx="minor">
+            <a:schemeClr val="lt1"/>
+          </a:fontRef>
+        </p:style>
+        <p:txBody>
+          <a:bodyPr rtlCol="0" anchor="ctr" wrap="square" tIns="18288"/>
+          <a:lstStyle/>
+          <a:p>
+            <a:pPr algn="ctr">
+              <a:defRPr sz="700" b="1">
+                <a:solidFill>
+                  <a:srgbClr val="FFFFFF"/>
+                </a:solidFill>
+              </a:defRPr>
+            </a:pPr>
+            <a:r>
+              <a:t>Need ~3, have 4</a:t>
+            </a:r>
+          </a:p>
+          <a:p>
+            <a:pPr algn="ctr">
+              <a:defRPr sz="700" b="0">
+                <a:solidFill>
+                  <a:srgbClr val="FFFFFF"/>
+                </a:solidFill>
+              </a:defRPr>
+            </a:pPr>
+            <a:r>
+              <a:t>✅ Comfortable</a:t>
+            </a:r>
+          </a:p>
+        </p:txBody>
+      </p:sp>
+      <p:sp>
+        <p:nvSpPr>
+          <p:cNvPr id="28" name="Rounded Rectangle 27"/>
+          <p:cNvSpPr/>
+          <p:nvPr/>
+        </p:nvSpPr>
+        <p:spPr>
+          <a:xfrm>
+            <a:off x="6510528" y="2834640"/>
+            <a:ext cx="1060704" cy="502920"/>
+          </a:xfrm>
+          <a:prstGeom prst="roundRect">
+            <a:avLst/>
+          </a:prstGeom>
+          <a:solidFill>
+            <a:srgbClr val="2E7D32"/>
+          </a:solidFill>
+          <a:ln>
+            <a:noFill/>
+          </a:ln>
+        </p:spPr>
+        <p:style>
+          <a:lnRef idx="1">
+            <a:schemeClr val="accent1"/>
+          </a:lnRef>
+          <a:fillRef idx="3">
+            <a:schemeClr val="accent1"/>
+          </a:fillRef>
+          <a:effectRef idx="2">
+            <a:schemeClr val="accent1"/>
+          </a:effectRef>
+          <a:fontRef idx="minor">
+            <a:schemeClr val="lt1"/>
+          </a:fontRef>
+        </p:style>
+        <p:txBody>
+          <a:bodyPr rtlCol="0" anchor="ctr" wrap="square" tIns="18288"/>
+          <a:lstStyle/>
+          <a:p>
+            <a:pPr algn="ctr">
+              <a:defRPr sz="700" b="1">
+                <a:solidFill>
+                  <a:srgbClr val="FFFFFF"/>
+                </a:solidFill>
+              </a:defRPr>
+            </a:pPr>
+            <a:r>
+              <a:t>Need ~4, have 5</a:t>
+            </a:r>
+          </a:p>
+          <a:p>
+            <a:pPr algn="ctr">
+              <a:defRPr sz="700" b="0">
+                <a:solidFill>
+                  <a:srgbClr val="FFFFFF"/>
+                </a:solidFill>
+              </a:defRPr>
+            </a:pPr>
+            <a:r>
+              <a:t>✅ Covered</a:t>
+            </a:r>
+          </a:p>
+        </p:txBody>
+      </p:sp>
+      <p:sp>
+        <p:nvSpPr>
+          <p:cNvPr id="29" name="Rounded Rectangle 28"/>
+          <p:cNvSpPr/>
+          <p:nvPr/>
+        </p:nvSpPr>
+        <p:spPr>
+          <a:xfrm>
+            <a:off x="7607808" y="2834640"/>
+            <a:ext cx="1060704" cy="502920"/>
+          </a:xfrm>
+          <a:prstGeom prst="roundRect">
+            <a:avLst/>
+          </a:prstGeom>
+          <a:solidFill>
+            <a:srgbClr val="F57C00"/>
+          </a:solidFill>
+          <a:ln>
+            <a:noFill/>
+          </a:ln>
+        </p:spPr>
+        <p:style>
+          <a:lnRef idx="1">
+            <a:schemeClr val="accent1"/>
+          </a:lnRef>
+          <a:fillRef idx="3">
+            <a:schemeClr val="accent1"/>
+          </a:fillRef>
+          <a:effectRef idx="2">
+            <a:schemeClr val="accent1"/>
+          </a:effectRef>
+          <a:fontRef idx="minor">
+            <a:schemeClr val="lt1"/>
+          </a:fontRef>
+        </p:style>
+        <p:txBody>
+          <a:bodyPr rtlCol="0" anchor="ctr" wrap="square" tIns="18288"/>
+          <a:lstStyle/>
+          <a:p>
+            <a:pPr algn="ctr">
+              <a:defRPr sz="700" b="1">
+                <a:solidFill>
+                  <a:srgbClr val="FFFFFF"/>
+                </a:solidFill>
+              </a:defRPr>
+            </a:pPr>
+            <a:r>
+              <a:t>Need ~5, have 5</a:t>
+            </a:r>
+          </a:p>
+          <a:p>
+            <a:pPr algn="ctr">
+              <a:defRPr sz="700" b="0">
+                <a:solidFill>
+                  <a:srgbClr val="FFFFFF"/>
+                </a:solidFill>
+              </a:defRPr>
+            </a:pPr>
+            <a:r>
+              <a:t>⚠ Tight</a:t>
+            </a:r>
+          </a:p>
+        </p:txBody>
+      </p:sp>
+      <p:sp>
+        <p:nvSpPr>
+          <p:cNvPr id="30" name="Rounded Rectangle 29"/>
+          <p:cNvSpPr/>
+          <p:nvPr/>
+        </p:nvSpPr>
+        <p:spPr>
+          <a:xfrm>
+            <a:off x="8705088" y="2834640"/>
+            <a:ext cx="3255264" cy="502920"/>
+          </a:xfrm>
+          <a:prstGeom prst="roundRect">
+            <a:avLst/>
+          </a:prstGeom>
+          <a:solidFill>
+            <a:srgbClr val="1565C0"/>
+          </a:solidFill>
+          <a:ln>
+            <a:noFill/>
+          </a:ln>
+        </p:spPr>
+        <p:style>
+          <a:lnRef idx="1">
+            <a:schemeClr val="accent1"/>
+          </a:lnRef>
+          <a:fillRef idx="3">
+            <a:schemeClr val="accent1"/>
+          </a:fillRef>
+          <a:effectRef idx="2">
+            <a:schemeClr val="accent1"/>
+          </a:effectRef>
+          <a:fontRef idx="minor">
+            <a:schemeClr val="lt1"/>
+          </a:fontRef>
+        </p:style>
+        <p:txBody>
+          <a:bodyPr rtlCol="0" anchor="ctr" wrap="square" tIns="18288"/>
+          <a:lstStyle/>
+          <a:p>
+            <a:pPr algn="ctr">
+              <a:defRPr sz="700" b="1">
+                <a:solidFill>
+                  <a:srgbClr val="FFFFFF"/>
+                </a:solidFill>
+              </a:defRPr>
+            </a:pPr>
+            <a:r>
+              <a:t>Need ~4, have 6</a:t>
+            </a:r>
+          </a:p>
+          <a:p>
+            <a:pPr algn="ctr">
+              <a:defRPr sz="700" b="0">
+                <a:solidFill>
+                  <a:srgbClr val="FFFFFF"/>
+                </a:solidFill>
+              </a:defRPr>
+            </a:pPr>
+            <a:r>
+              <a:t>✅ Comfortable</a:t>
+            </a:r>
+          </a:p>
+        </p:txBody>
+      </p:sp>
+      <p:sp>
+        <p:nvSpPr>
+          <p:cNvPr id="31" name="Rounded Rectangle 30"/>
+          <p:cNvSpPr/>
+          <p:nvPr/>
+        </p:nvSpPr>
+        <p:spPr>
+          <a:xfrm>
+            <a:off x="457200" y="3520440"/>
+            <a:ext cx="11247120" cy="3063240"/>
+          </a:xfrm>
+          <a:prstGeom prst="roundRect">
+            <a:avLst/>
+          </a:prstGeom>
+          <a:solidFill>
+            <a:srgbClr val="E8EAF6"/>
+          </a:solidFill>
+          <a:ln>
+            <a:noFill/>
+          </a:ln>
+        </p:spPr>
+        <p:style>
+          <a:lnRef idx="1">
+            <a:schemeClr val="accent1"/>
+          </a:lnRef>
+          <a:fillRef idx="3">
+            <a:schemeClr val="accent1"/>
+          </a:fillRef>
+          <a:effectRef idx="2">
+            <a:schemeClr val="accent1"/>
+          </a:effectRef>
+          <a:fontRef idx="minor">
+            <a:schemeClr val="lt1"/>
+          </a:fontRef>
+        </p:style>
+        <p:txBody>
+          <a:bodyPr rtlCol="0" anchor="ctr" wrap="square" lIns="182880" rIns="182880" tIns="137160"/>
+          <a:lstStyle/>
+          <a:p>
+            <a:pPr algn="ctr">
+              <a:spcAft>
+                <a:spcPts val="600"/>
+              </a:spcAft>
+              <a:defRPr sz="1400" b="1">
+                <a:solidFill>
+                  <a:srgbClr val="1A237E"/>
+                </a:solidFill>
+              </a:defRPr>
+            </a:pPr>
+            <a:r>
+              <a:t>Why These 3 Hires, Why These Dates</a:t>
+            </a:r>
+          </a:p>
+          <a:p>
+            <a:pPr>
+              <a:spcAft>
                 <a:spcPts val="400"/>
-              </a:spcBef>
-            </a:pPr>
-          </a:p>
-          <a:p>
+              </a:spcAft>
+            </a:pPr>
             <a:r>
               <a:rPr sz="1000" b="1">
                 <a:solidFill>
                   <a:srgbClr val="1A237E"/>
                 </a:solidFill>
               </a:rPr>
-              <a:t>Why 1-at-a-time: </a:t>
+              <a:t>Hire #1 — Sep 2026: </a:t>
             </a:r>
             <a:r>
               <a:rPr sz="1000">
@@ -21068,7 +22590,117 @@
                   <a:srgbClr val="1E1E1E"/>
                 </a:solidFill>
               </a:rPr>
-              <a:t>Manager does most training. Each hire needs ~2 months ramp-up. Staggering matches the schedule's ramp-up pattern and prevents training overload.</a:t>
+              <a:t>Sep-Dec has 5 active projects needing ~3 developers. With 3 existing developers plus this hire ramping up, we cover it. This hire takes on reservation/knowledge platform work while senior developers focus on core AI infrastructure.</a:t>
+            </a:r>
+          </a:p>
+          <a:p>
+            <a:pPr>
+              <a:spcAft>
+                <a:spcPts val="400"/>
+              </a:spcAft>
+            </a:pPr>
+            <a:r>
+              <a:rPr sz="1000" b="1">
+                <a:solidFill>
+                  <a:srgbClr val="1A237E"/>
+                </a:solidFill>
+              </a:rPr>
+              <a:t>Hire #2 — Apr 2027: </a:t>
+            </a:r>
+            <a:r>
+              <a:rPr sz="1000">
+                <a:solidFill>
+                  <a:srgbClr val="1E1E1E"/>
+                </a:solidFill>
+              </a:rPr>
+              <a:t>Jan-Jun 2027 has 5 active projects needing ~4 developers (including 3 large ones). Second hire absorbs governance/staff-builder support so existing developers stay focused on backend separation.</a:t>
+            </a:r>
+          </a:p>
+          <a:p>
+            <a:pPr>
+              <a:spcAft>
+                <a:spcPts val="400"/>
+              </a:spcAft>
+            </a:pPr>
+            <a:r>
+              <a:rPr sz="1000" b="1">
+                <a:solidFill>
+                  <a:srgbClr val="1A237E"/>
+                </a:solidFill>
+              </a:rPr>
+              <a:t>Hire #3 — Jan 2028: </a:t>
+            </a:r>
+            <a:r>
+              <a:rPr sz="1000">
+                <a:solidFill>
+                  <a:srgbClr val="1E1E1E"/>
+                </a:solidFill>
+              </a:rPr>
+              <a:t>Jul-Dec 2028 adds SaaS foundation and Corporate Bohr SaaS on top of ongoing separation work — 6 projects needing ~5 developers. Third hire takes on SaaS foundation.</a:t>
+            </a:r>
+          </a:p>
+          <a:p>
+            <a:pPr>
+              <a:spcAft>
+                <a:spcPts val="400"/>
+              </a:spcAft>
+            </a:pPr>
+            <a:r>
+              <a:rPr sz="1000" b="1">
+                <a:solidFill>
+                  <a:srgbClr val="1A237E"/>
+                </a:solidFill>
+              </a:rPr>
+              <a:t>Schedule adjustment: </a:t>
+            </a:r>
+            <a:r>
+              <a:rPr sz="1000">
+                <a:solidFill>
+                  <a:srgbClr val="1E1E1E"/>
+                </a:solidFill>
+              </a:rPr>
+              <a:t>4 project starts (PLAT-01, APP-SEP-01, GOV-01, IAGPT-04) moved from Dec 2026 to Jan 2027 to match hiring pace. Impact is minimal — 1-month slip on multi-year projects.</a:t>
+            </a:r>
+          </a:p>
+          <a:p>
+            <a:pPr>
+              <a:spcAft>
+                <a:spcPts val="400"/>
+              </a:spcAft>
+            </a:pPr>
+            <a:r>
+              <a:rPr sz="1000" b="1">
+                <a:solidFill>
+                  <a:srgbClr val="2E7D32"/>
+                </a:solidFill>
+              </a:rPr>
+              <a:t>What to look for: </a:t>
+            </a:r>
+            <a:r>
+              <a:rPr sz="1000">
+                <a:solidFill>
+                  <a:srgbClr val="1E1E1E"/>
+                </a:solidFill>
+              </a:rPr>
+              <a:t>Solid dev fundamentals · Git/PR familiarity · Communication skills · Full-stack (Django/Go + Vue) · 2-4 years experience · Independent after 2-month training</a:t>
+            </a:r>
+          </a:p>
+          <a:p>
+            <a:r>
+              <a:rPr sz="1000" b="1">
+                <a:solidFill>
+                  <a:srgbClr val="C62828"/>
+                </a:solidFill>
+              </a:rPr>
+              <a:t>What's NOT required: </a:t>
+            </a:r>
+            <a:r>
+              <a:rPr sz="1000">
+                <a:solidFill>
+                  <a:srgbClr val="1E1E1E"/>
+                </a:solidFill>
+              </a:rPr>
+              <a:t>AI/ML expertise · Kubernetes/microservices · SaaS platform experience · Senior architect-level · Education industry knowledge</a:t>
             </a:r>
           </a:p>
         </p:txBody>

</xml_diff>